<commit_message>
chnage in documentation and powerpoint
</commit_message>
<xml_diff>
--- a/2nd sem final presentation.pptx
+++ b/2nd sem final presentation.pptx
@@ -147,7 +147,7 @@
           <p:cNvPr id="2" name="Title 1">
             <a:extLst>
               <a:ext uri="{FF2B5EF4-FFF2-40B4-BE49-F238E27FC236}">
-                <a16:creationId xmlns:a16="http://schemas.microsoft.com/office/drawing/2014/main" xmlns="" id="{C4E26AE7-911E-97F7-90DC-57CC6774223E}"/>
+                <a16:creationId xmlns:a16="http://schemas.microsoft.com/office/drawing/2014/main" id="{C4E26AE7-911E-97F7-90DC-57CC6774223E}"/>
               </a:ext>
             </a:extLst>
           </p:cNvPr>
@@ -184,7 +184,7 @@
           <p:cNvPr id="3" name="Subtitle 2">
             <a:extLst>
               <a:ext uri="{FF2B5EF4-FFF2-40B4-BE49-F238E27FC236}">
-                <a16:creationId xmlns:a16="http://schemas.microsoft.com/office/drawing/2014/main" xmlns="" id="{98127FD1-24CC-48DA-F096-30197D813BB9}"/>
+                <a16:creationId xmlns:a16="http://schemas.microsoft.com/office/drawing/2014/main" id="{98127FD1-24CC-48DA-F096-30197D813BB9}"/>
               </a:ext>
             </a:extLst>
           </p:cNvPr>
@@ -254,7 +254,7 @@
           <p:cNvPr id="4" name="Date Placeholder 3">
             <a:extLst>
               <a:ext uri="{FF2B5EF4-FFF2-40B4-BE49-F238E27FC236}">
-                <a16:creationId xmlns:a16="http://schemas.microsoft.com/office/drawing/2014/main" xmlns="" id="{53CDE153-1672-8941-4330-64F58EBF59FB}"/>
+                <a16:creationId xmlns:a16="http://schemas.microsoft.com/office/drawing/2014/main" id="{53CDE153-1672-8941-4330-64F58EBF59FB}"/>
               </a:ext>
             </a:extLst>
           </p:cNvPr>
@@ -283,7 +283,7 @@
           <p:cNvPr id="5" name="Footer Placeholder 4">
             <a:extLst>
               <a:ext uri="{FF2B5EF4-FFF2-40B4-BE49-F238E27FC236}">
-                <a16:creationId xmlns:a16="http://schemas.microsoft.com/office/drawing/2014/main" xmlns="" id="{1EACCBBF-80B2-A6DB-0EB5-356564D5D1CB}"/>
+                <a16:creationId xmlns:a16="http://schemas.microsoft.com/office/drawing/2014/main" id="{1EACCBBF-80B2-A6DB-0EB5-356564D5D1CB}"/>
               </a:ext>
             </a:extLst>
           </p:cNvPr>
@@ -308,7 +308,7 @@
           <p:cNvPr id="6" name="Slide Number Placeholder 5">
             <a:extLst>
               <a:ext uri="{FF2B5EF4-FFF2-40B4-BE49-F238E27FC236}">
-                <a16:creationId xmlns:a16="http://schemas.microsoft.com/office/drawing/2014/main" xmlns="" id="{F8F33690-8F48-8AA2-5DD5-2CB340D1EDAC}"/>
+                <a16:creationId xmlns:a16="http://schemas.microsoft.com/office/drawing/2014/main" id="{F8F33690-8F48-8AA2-5DD5-2CB340D1EDAC}"/>
               </a:ext>
             </a:extLst>
           </p:cNvPr>
@@ -367,7 +367,7 @@
           <p:cNvPr id="2" name="Title 1">
             <a:extLst>
               <a:ext uri="{FF2B5EF4-FFF2-40B4-BE49-F238E27FC236}">
-                <a16:creationId xmlns:a16="http://schemas.microsoft.com/office/drawing/2014/main" xmlns="" id="{37BCA827-20F9-FC36-1DA7-827C94B22F26}"/>
+                <a16:creationId xmlns:a16="http://schemas.microsoft.com/office/drawing/2014/main" id="{37BCA827-20F9-FC36-1DA7-827C94B22F26}"/>
               </a:ext>
             </a:extLst>
           </p:cNvPr>
@@ -395,7 +395,7 @@
           <p:cNvPr id="3" name="Vertical Text Placeholder 2">
             <a:extLst>
               <a:ext uri="{FF2B5EF4-FFF2-40B4-BE49-F238E27FC236}">
-                <a16:creationId xmlns:a16="http://schemas.microsoft.com/office/drawing/2014/main" xmlns="" id="{FAF8956B-B870-DB88-5702-3466DE95D2D1}"/>
+                <a16:creationId xmlns:a16="http://schemas.microsoft.com/office/drawing/2014/main" id="{FAF8956B-B870-DB88-5702-3466DE95D2D1}"/>
               </a:ext>
             </a:extLst>
           </p:cNvPr>
@@ -452,7 +452,7 @@
           <p:cNvPr id="4" name="Date Placeholder 3">
             <a:extLst>
               <a:ext uri="{FF2B5EF4-FFF2-40B4-BE49-F238E27FC236}">
-                <a16:creationId xmlns:a16="http://schemas.microsoft.com/office/drawing/2014/main" xmlns="" id="{D3A7D5CE-FDF1-38EB-5981-24720036DD41}"/>
+                <a16:creationId xmlns:a16="http://schemas.microsoft.com/office/drawing/2014/main" id="{D3A7D5CE-FDF1-38EB-5981-24720036DD41}"/>
               </a:ext>
             </a:extLst>
           </p:cNvPr>
@@ -481,7 +481,7 @@
           <p:cNvPr id="5" name="Footer Placeholder 4">
             <a:extLst>
               <a:ext uri="{FF2B5EF4-FFF2-40B4-BE49-F238E27FC236}">
-                <a16:creationId xmlns:a16="http://schemas.microsoft.com/office/drawing/2014/main" xmlns="" id="{CC33B160-42FB-E486-1073-20CF7CCC3BB7}"/>
+                <a16:creationId xmlns:a16="http://schemas.microsoft.com/office/drawing/2014/main" id="{CC33B160-42FB-E486-1073-20CF7CCC3BB7}"/>
               </a:ext>
             </a:extLst>
           </p:cNvPr>
@@ -506,7 +506,7 @@
           <p:cNvPr id="6" name="Slide Number Placeholder 5">
             <a:extLst>
               <a:ext uri="{FF2B5EF4-FFF2-40B4-BE49-F238E27FC236}">
-                <a16:creationId xmlns:a16="http://schemas.microsoft.com/office/drawing/2014/main" xmlns="" id="{7D7D6441-F9A6-5398-550D-415D3CDFB43A}"/>
+                <a16:creationId xmlns:a16="http://schemas.microsoft.com/office/drawing/2014/main" id="{7D7D6441-F9A6-5398-550D-415D3CDFB43A}"/>
               </a:ext>
             </a:extLst>
           </p:cNvPr>
@@ -565,7 +565,7 @@
           <p:cNvPr id="2" name="Vertical Title 1">
             <a:extLst>
               <a:ext uri="{FF2B5EF4-FFF2-40B4-BE49-F238E27FC236}">
-                <a16:creationId xmlns:a16="http://schemas.microsoft.com/office/drawing/2014/main" xmlns="" id="{2B9AD8A6-1443-5CF8-B0A0-DC7212A8305D}"/>
+                <a16:creationId xmlns:a16="http://schemas.microsoft.com/office/drawing/2014/main" id="{2B9AD8A6-1443-5CF8-B0A0-DC7212A8305D}"/>
               </a:ext>
             </a:extLst>
           </p:cNvPr>
@@ -598,7 +598,7 @@
           <p:cNvPr id="3" name="Vertical Text Placeholder 2">
             <a:extLst>
               <a:ext uri="{FF2B5EF4-FFF2-40B4-BE49-F238E27FC236}">
-                <a16:creationId xmlns:a16="http://schemas.microsoft.com/office/drawing/2014/main" xmlns="" id="{1336A049-DE16-832E-0754-B4C535259D20}"/>
+                <a16:creationId xmlns:a16="http://schemas.microsoft.com/office/drawing/2014/main" id="{1336A049-DE16-832E-0754-B4C535259D20}"/>
               </a:ext>
             </a:extLst>
           </p:cNvPr>
@@ -660,7 +660,7 @@
           <p:cNvPr id="4" name="Date Placeholder 3">
             <a:extLst>
               <a:ext uri="{FF2B5EF4-FFF2-40B4-BE49-F238E27FC236}">
-                <a16:creationId xmlns:a16="http://schemas.microsoft.com/office/drawing/2014/main" xmlns="" id="{3EFEC61F-9515-9E90-9383-406A72657605}"/>
+                <a16:creationId xmlns:a16="http://schemas.microsoft.com/office/drawing/2014/main" id="{3EFEC61F-9515-9E90-9383-406A72657605}"/>
               </a:ext>
             </a:extLst>
           </p:cNvPr>
@@ -689,7 +689,7 @@
           <p:cNvPr id="5" name="Footer Placeholder 4">
             <a:extLst>
               <a:ext uri="{FF2B5EF4-FFF2-40B4-BE49-F238E27FC236}">
-                <a16:creationId xmlns:a16="http://schemas.microsoft.com/office/drawing/2014/main" xmlns="" id="{CCECA544-3170-192D-C1ED-108C7F20BC9C}"/>
+                <a16:creationId xmlns:a16="http://schemas.microsoft.com/office/drawing/2014/main" id="{CCECA544-3170-192D-C1ED-108C7F20BC9C}"/>
               </a:ext>
             </a:extLst>
           </p:cNvPr>
@@ -714,7 +714,7 @@
           <p:cNvPr id="6" name="Slide Number Placeholder 5">
             <a:extLst>
               <a:ext uri="{FF2B5EF4-FFF2-40B4-BE49-F238E27FC236}">
-                <a16:creationId xmlns:a16="http://schemas.microsoft.com/office/drawing/2014/main" xmlns="" id="{13A333BF-8D8D-E28A-B6A3-A25B45DEB6D1}"/>
+                <a16:creationId xmlns:a16="http://schemas.microsoft.com/office/drawing/2014/main" id="{13A333BF-8D8D-E28A-B6A3-A25B45DEB6D1}"/>
               </a:ext>
             </a:extLst>
           </p:cNvPr>
@@ -773,7 +773,7 @@
           <p:cNvPr id="2" name="Title 1">
             <a:extLst>
               <a:ext uri="{FF2B5EF4-FFF2-40B4-BE49-F238E27FC236}">
-                <a16:creationId xmlns:a16="http://schemas.microsoft.com/office/drawing/2014/main" xmlns="" id="{0E75C88C-6AF6-E40C-7B1D-B2D0FEAA956C}"/>
+                <a16:creationId xmlns:a16="http://schemas.microsoft.com/office/drawing/2014/main" id="{0E75C88C-6AF6-E40C-7B1D-B2D0FEAA956C}"/>
               </a:ext>
             </a:extLst>
           </p:cNvPr>
@@ -801,7 +801,7 @@
           <p:cNvPr id="3" name="Content Placeholder 2">
             <a:extLst>
               <a:ext uri="{FF2B5EF4-FFF2-40B4-BE49-F238E27FC236}">
-                <a16:creationId xmlns:a16="http://schemas.microsoft.com/office/drawing/2014/main" xmlns="" id="{1CF08466-B11B-56F5-AC2A-421498AB2022}"/>
+                <a16:creationId xmlns:a16="http://schemas.microsoft.com/office/drawing/2014/main" id="{1CF08466-B11B-56F5-AC2A-421498AB2022}"/>
               </a:ext>
             </a:extLst>
           </p:cNvPr>
@@ -858,7 +858,7 @@
           <p:cNvPr id="4" name="Date Placeholder 3">
             <a:extLst>
               <a:ext uri="{FF2B5EF4-FFF2-40B4-BE49-F238E27FC236}">
-                <a16:creationId xmlns:a16="http://schemas.microsoft.com/office/drawing/2014/main" xmlns="" id="{6F244DE3-6B2E-37F4-62F6-D09693D50DBA}"/>
+                <a16:creationId xmlns:a16="http://schemas.microsoft.com/office/drawing/2014/main" id="{6F244DE3-6B2E-37F4-62F6-D09693D50DBA}"/>
               </a:ext>
             </a:extLst>
           </p:cNvPr>
@@ -887,7 +887,7 @@
           <p:cNvPr id="5" name="Footer Placeholder 4">
             <a:extLst>
               <a:ext uri="{FF2B5EF4-FFF2-40B4-BE49-F238E27FC236}">
-                <a16:creationId xmlns:a16="http://schemas.microsoft.com/office/drawing/2014/main" xmlns="" id="{5ADEA595-1D33-1FAF-69FB-AF8DF9EAC294}"/>
+                <a16:creationId xmlns:a16="http://schemas.microsoft.com/office/drawing/2014/main" id="{5ADEA595-1D33-1FAF-69FB-AF8DF9EAC294}"/>
               </a:ext>
             </a:extLst>
           </p:cNvPr>
@@ -912,7 +912,7 @@
           <p:cNvPr id="6" name="Slide Number Placeholder 5">
             <a:extLst>
               <a:ext uri="{FF2B5EF4-FFF2-40B4-BE49-F238E27FC236}">
-                <a16:creationId xmlns:a16="http://schemas.microsoft.com/office/drawing/2014/main" xmlns="" id="{BB3328DC-FC11-A62A-356D-DD63D1369AC9}"/>
+                <a16:creationId xmlns:a16="http://schemas.microsoft.com/office/drawing/2014/main" id="{BB3328DC-FC11-A62A-356D-DD63D1369AC9}"/>
               </a:ext>
             </a:extLst>
           </p:cNvPr>
@@ -971,7 +971,7 @@
           <p:cNvPr id="2" name="Title 1">
             <a:extLst>
               <a:ext uri="{FF2B5EF4-FFF2-40B4-BE49-F238E27FC236}">
-                <a16:creationId xmlns:a16="http://schemas.microsoft.com/office/drawing/2014/main" xmlns="" id="{FB01DAC3-7FEB-C4FF-DE46-BA155AA820BF}"/>
+                <a16:creationId xmlns:a16="http://schemas.microsoft.com/office/drawing/2014/main" id="{FB01DAC3-7FEB-C4FF-DE46-BA155AA820BF}"/>
               </a:ext>
             </a:extLst>
           </p:cNvPr>
@@ -1008,7 +1008,7 @@
           <p:cNvPr id="3" name="Text Placeholder 2">
             <a:extLst>
               <a:ext uri="{FF2B5EF4-FFF2-40B4-BE49-F238E27FC236}">
-                <a16:creationId xmlns:a16="http://schemas.microsoft.com/office/drawing/2014/main" xmlns="" id="{72F22055-BDA8-9EC5-57C5-9EB70D910048}"/>
+                <a16:creationId xmlns:a16="http://schemas.microsoft.com/office/drawing/2014/main" id="{72F22055-BDA8-9EC5-57C5-9EB70D910048}"/>
               </a:ext>
             </a:extLst>
           </p:cNvPr>
@@ -1133,7 +1133,7 @@
           <p:cNvPr id="4" name="Date Placeholder 3">
             <a:extLst>
               <a:ext uri="{FF2B5EF4-FFF2-40B4-BE49-F238E27FC236}">
-                <a16:creationId xmlns:a16="http://schemas.microsoft.com/office/drawing/2014/main" xmlns="" id="{65FA28B4-AE90-FDD9-0A4D-FC774CD8757A}"/>
+                <a16:creationId xmlns:a16="http://schemas.microsoft.com/office/drawing/2014/main" id="{65FA28B4-AE90-FDD9-0A4D-FC774CD8757A}"/>
               </a:ext>
             </a:extLst>
           </p:cNvPr>
@@ -1162,7 +1162,7 @@
           <p:cNvPr id="5" name="Footer Placeholder 4">
             <a:extLst>
               <a:ext uri="{FF2B5EF4-FFF2-40B4-BE49-F238E27FC236}">
-                <a16:creationId xmlns:a16="http://schemas.microsoft.com/office/drawing/2014/main" xmlns="" id="{9F5F3C4F-7E86-CE2A-E7C7-E31C80772628}"/>
+                <a16:creationId xmlns:a16="http://schemas.microsoft.com/office/drawing/2014/main" id="{9F5F3C4F-7E86-CE2A-E7C7-E31C80772628}"/>
               </a:ext>
             </a:extLst>
           </p:cNvPr>
@@ -1187,7 +1187,7 @@
           <p:cNvPr id="6" name="Slide Number Placeholder 5">
             <a:extLst>
               <a:ext uri="{FF2B5EF4-FFF2-40B4-BE49-F238E27FC236}">
-                <a16:creationId xmlns:a16="http://schemas.microsoft.com/office/drawing/2014/main" xmlns="" id="{953B46B8-A7E8-B944-B322-654BDBF09CF9}"/>
+                <a16:creationId xmlns:a16="http://schemas.microsoft.com/office/drawing/2014/main" id="{953B46B8-A7E8-B944-B322-654BDBF09CF9}"/>
               </a:ext>
             </a:extLst>
           </p:cNvPr>
@@ -1246,7 +1246,7 @@
           <p:cNvPr id="2" name="Title 1">
             <a:extLst>
               <a:ext uri="{FF2B5EF4-FFF2-40B4-BE49-F238E27FC236}">
-                <a16:creationId xmlns:a16="http://schemas.microsoft.com/office/drawing/2014/main" xmlns="" id="{99FDD089-92F1-CE0B-B25C-8F0D2AFE9798}"/>
+                <a16:creationId xmlns:a16="http://schemas.microsoft.com/office/drawing/2014/main" id="{99FDD089-92F1-CE0B-B25C-8F0D2AFE9798}"/>
               </a:ext>
             </a:extLst>
           </p:cNvPr>
@@ -1274,7 +1274,7 @@
           <p:cNvPr id="3" name="Content Placeholder 2">
             <a:extLst>
               <a:ext uri="{FF2B5EF4-FFF2-40B4-BE49-F238E27FC236}">
-                <a16:creationId xmlns:a16="http://schemas.microsoft.com/office/drawing/2014/main" xmlns="" id="{2D60BFC1-69ED-BA70-558B-36DA4BC64DFC}"/>
+                <a16:creationId xmlns:a16="http://schemas.microsoft.com/office/drawing/2014/main" id="{2D60BFC1-69ED-BA70-558B-36DA4BC64DFC}"/>
               </a:ext>
             </a:extLst>
           </p:cNvPr>
@@ -1336,7 +1336,7 @@
           <p:cNvPr id="4" name="Content Placeholder 3">
             <a:extLst>
               <a:ext uri="{FF2B5EF4-FFF2-40B4-BE49-F238E27FC236}">
-                <a16:creationId xmlns:a16="http://schemas.microsoft.com/office/drawing/2014/main" xmlns="" id="{20507B1A-61F6-5082-9D91-E531C878BD70}"/>
+                <a16:creationId xmlns:a16="http://schemas.microsoft.com/office/drawing/2014/main" id="{20507B1A-61F6-5082-9D91-E531C878BD70}"/>
               </a:ext>
             </a:extLst>
           </p:cNvPr>
@@ -1398,7 +1398,7 @@
           <p:cNvPr id="5" name="Date Placeholder 4">
             <a:extLst>
               <a:ext uri="{FF2B5EF4-FFF2-40B4-BE49-F238E27FC236}">
-                <a16:creationId xmlns:a16="http://schemas.microsoft.com/office/drawing/2014/main" xmlns="" id="{8F63CFB7-6543-C803-DA07-3A9DDFE0C609}"/>
+                <a16:creationId xmlns:a16="http://schemas.microsoft.com/office/drawing/2014/main" id="{8F63CFB7-6543-C803-DA07-3A9DDFE0C609}"/>
               </a:ext>
             </a:extLst>
           </p:cNvPr>
@@ -1427,7 +1427,7 @@
           <p:cNvPr id="6" name="Footer Placeholder 5">
             <a:extLst>
               <a:ext uri="{FF2B5EF4-FFF2-40B4-BE49-F238E27FC236}">
-                <a16:creationId xmlns:a16="http://schemas.microsoft.com/office/drawing/2014/main" xmlns="" id="{A2674DB0-FEF9-599F-8C5B-170E24974326}"/>
+                <a16:creationId xmlns:a16="http://schemas.microsoft.com/office/drawing/2014/main" id="{A2674DB0-FEF9-599F-8C5B-170E24974326}"/>
               </a:ext>
             </a:extLst>
           </p:cNvPr>
@@ -1452,7 +1452,7 @@
           <p:cNvPr id="7" name="Slide Number Placeholder 6">
             <a:extLst>
               <a:ext uri="{FF2B5EF4-FFF2-40B4-BE49-F238E27FC236}">
-                <a16:creationId xmlns:a16="http://schemas.microsoft.com/office/drawing/2014/main" xmlns="" id="{8D43C5C5-89DC-EC60-8E33-AE5CED8A737D}"/>
+                <a16:creationId xmlns:a16="http://schemas.microsoft.com/office/drawing/2014/main" id="{8D43C5C5-89DC-EC60-8E33-AE5CED8A737D}"/>
               </a:ext>
             </a:extLst>
           </p:cNvPr>
@@ -1511,7 +1511,7 @@
           <p:cNvPr id="2" name="Title 1">
             <a:extLst>
               <a:ext uri="{FF2B5EF4-FFF2-40B4-BE49-F238E27FC236}">
-                <a16:creationId xmlns:a16="http://schemas.microsoft.com/office/drawing/2014/main" xmlns="" id="{8746755F-6B9C-A611-C217-6B5A92096ED5}"/>
+                <a16:creationId xmlns:a16="http://schemas.microsoft.com/office/drawing/2014/main" id="{8746755F-6B9C-A611-C217-6B5A92096ED5}"/>
               </a:ext>
             </a:extLst>
           </p:cNvPr>
@@ -1544,7 +1544,7 @@
           <p:cNvPr id="3" name="Text Placeholder 2">
             <a:extLst>
               <a:ext uri="{FF2B5EF4-FFF2-40B4-BE49-F238E27FC236}">
-                <a16:creationId xmlns:a16="http://schemas.microsoft.com/office/drawing/2014/main" xmlns="" id="{26C4B97A-CEAE-E23A-B5D0-C528FD6F1021}"/>
+                <a16:creationId xmlns:a16="http://schemas.microsoft.com/office/drawing/2014/main" id="{26C4B97A-CEAE-E23A-B5D0-C528FD6F1021}"/>
               </a:ext>
             </a:extLst>
           </p:cNvPr>
@@ -1615,7 +1615,7 @@
           <p:cNvPr id="4" name="Content Placeholder 3">
             <a:extLst>
               <a:ext uri="{FF2B5EF4-FFF2-40B4-BE49-F238E27FC236}">
-                <a16:creationId xmlns:a16="http://schemas.microsoft.com/office/drawing/2014/main" xmlns="" id="{3D1A3465-CAF8-C4A0-B417-1FD38E1209C7}"/>
+                <a16:creationId xmlns:a16="http://schemas.microsoft.com/office/drawing/2014/main" id="{3D1A3465-CAF8-C4A0-B417-1FD38E1209C7}"/>
               </a:ext>
             </a:extLst>
           </p:cNvPr>
@@ -1677,7 +1677,7 @@
           <p:cNvPr id="5" name="Text Placeholder 4">
             <a:extLst>
               <a:ext uri="{FF2B5EF4-FFF2-40B4-BE49-F238E27FC236}">
-                <a16:creationId xmlns:a16="http://schemas.microsoft.com/office/drawing/2014/main" xmlns="" id="{A96E4927-CA74-03C1-FF96-9BD8F6C75BFA}"/>
+                <a16:creationId xmlns:a16="http://schemas.microsoft.com/office/drawing/2014/main" id="{A96E4927-CA74-03C1-FF96-9BD8F6C75BFA}"/>
               </a:ext>
             </a:extLst>
           </p:cNvPr>
@@ -1748,7 +1748,7 @@
           <p:cNvPr id="6" name="Content Placeholder 5">
             <a:extLst>
               <a:ext uri="{FF2B5EF4-FFF2-40B4-BE49-F238E27FC236}">
-                <a16:creationId xmlns:a16="http://schemas.microsoft.com/office/drawing/2014/main" xmlns="" id="{776B05E8-CC52-BF11-535B-DD5F3F7A4C49}"/>
+                <a16:creationId xmlns:a16="http://schemas.microsoft.com/office/drawing/2014/main" id="{776B05E8-CC52-BF11-535B-DD5F3F7A4C49}"/>
               </a:ext>
             </a:extLst>
           </p:cNvPr>
@@ -1810,7 +1810,7 @@
           <p:cNvPr id="7" name="Date Placeholder 6">
             <a:extLst>
               <a:ext uri="{FF2B5EF4-FFF2-40B4-BE49-F238E27FC236}">
-                <a16:creationId xmlns:a16="http://schemas.microsoft.com/office/drawing/2014/main" xmlns="" id="{762B8625-6D65-2904-3740-AEA5D078BD50}"/>
+                <a16:creationId xmlns:a16="http://schemas.microsoft.com/office/drawing/2014/main" id="{762B8625-6D65-2904-3740-AEA5D078BD50}"/>
               </a:ext>
             </a:extLst>
           </p:cNvPr>
@@ -1839,7 +1839,7 @@
           <p:cNvPr id="8" name="Footer Placeholder 7">
             <a:extLst>
               <a:ext uri="{FF2B5EF4-FFF2-40B4-BE49-F238E27FC236}">
-                <a16:creationId xmlns:a16="http://schemas.microsoft.com/office/drawing/2014/main" xmlns="" id="{8C95EFDA-49E2-B8B6-F841-35F3ED6828A8}"/>
+                <a16:creationId xmlns:a16="http://schemas.microsoft.com/office/drawing/2014/main" id="{8C95EFDA-49E2-B8B6-F841-35F3ED6828A8}"/>
               </a:ext>
             </a:extLst>
           </p:cNvPr>
@@ -1864,7 +1864,7 @@
           <p:cNvPr id="9" name="Slide Number Placeholder 8">
             <a:extLst>
               <a:ext uri="{FF2B5EF4-FFF2-40B4-BE49-F238E27FC236}">
-                <a16:creationId xmlns:a16="http://schemas.microsoft.com/office/drawing/2014/main" xmlns="" id="{FC3D7B08-9700-FAAB-B9FC-554F6A2A6FF5}"/>
+                <a16:creationId xmlns:a16="http://schemas.microsoft.com/office/drawing/2014/main" id="{FC3D7B08-9700-FAAB-B9FC-554F6A2A6FF5}"/>
               </a:ext>
             </a:extLst>
           </p:cNvPr>
@@ -1923,7 +1923,7 @@
           <p:cNvPr id="2" name="Title 1">
             <a:extLst>
               <a:ext uri="{FF2B5EF4-FFF2-40B4-BE49-F238E27FC236}">
-                <a16:creationId xmlns:a16="http://schemas.microsoft.com/office/drawing/2014/main" xmlns="" id="{5F578283-CA27-5BBE-3B69-A7AE24427070}"/>
+                <a16:creationId xmlns:a16="http://schemas.microsoft.com/office/drawing/2014/main" id="{5F578283-CA27-5BBE-3B69-A7AE24427070}"/>
               </a:ext>
             </a:extLst>
           </p:cNvPr>
@@ -1951,7 +1951,7 @@
           <p:cNvPr id="3" name="Date Placeholder 2">
             <a:extLst>
               <a:ext uri="{FF2B5EF4-FFF2-40B4-BE49-F238E27FC236}">
-                <a16:creationId xmlns:a16="http://schemas.microsoft.com/office/drawing/2014/main" xmlns="" id="{9799CE10-1BD2-E4EC-3052-8DB1E5A5B200}"/>
+                <a16:creationId xmlns:a16="http://schemas.microsoft.com/office/drawing/2014/main" id="{9799CE10-1BD2-E4EC-3052-8DB1E5A5B200}"/>
               </a:ext>
             </a:extLst>
           </p:cNvPr>
@@ -1980,7 +1980,7 @@
           <p:cNvPr id="4" name="Footer Placeholder 3">
             <a:extLst>
               <a:ext uri="{FF2B5EF4-FFF2-40B4-BE49-F238E27FC236}">
-                <a16:creationId xmlns:a16="http://schemas.microsoft.com/office/drawing/2014/main" xmlns="" id="{1BEF9561-3860-CD15-455C-89D3BB540767}"/>
+                <a16:creationId xmlns:a16="http://schemas.microsoft.com/office/drawing/2014/main" id="{1BEF9561-3860-CD15-455C-89D3BB540767}"/>
               </a:ext>
             </a:extLst>
           </p:cNvPr>
@@ -2005,7 +2005,7 @@
           <p:cNvPr id="5" name="Slide Number Placeholder 4">
             <a:extLst>
               <a:ext uri="{FF2B5EF4-FFF2-40B4-BE49-F238E27FC236}">
-                <a16:creationId xmlns:a16="http://schemas.microsoft.com/office/drawing/2014/main" xmlns="" id="{AC6F9450-FDA4-513C-0BBB-E527C348F30F}"/>
+                <a16:creationId xmlns:a16="http://schemas.microsoft.com/office/drawing/2014/main" id="{AC6F9450-FDA4-513C-0BBB-E527C348F30F}"/>
               </a:ext>
             </a:extLst>
           </p:cNvPr>
@@ -2064,7 +2064,7 @@
           <p:cNvPr id="2" name="Date Placeholder 1">
             <a:extLst>
               <a:ext uri="{FF2B5EF4-FFF2-40B4-BE49-F238E27FC236}">
-                <a16:creationId xmlns:a16="http://schemas.microsoft.com/office/drawing/2014/main" xmlns="" id="{FD935C6A-2B80-6605-16F4-543A28629475}"/>
+                <a16:creationId xmlns:a16="http://schemas.microsoft.com/office/drawing/2014/main" id="{FD935C6A-2B80-6605-16F4-543A28629475}"/>
               </a:ext>
             </a:extLst>
           </p:cNvPr>
@@ -2093,7 +2093,7 @@
           <p:cNvPr id="3" name="Footer Placeholder 2">
             <a:extLst>
               <a:ext uri="{FF2B5EF4-FFF2-40B4-BE49-F238E27FC236}">
-                <a16:creationId xmlns:a16="http://schemas.microsoft.com/office/drawing/2014/main" xmlns="" id="{DE30E863-D0D0-4377-C41B-91121E1B5522}"/>
+                <a16:creationId xmlns:a16="http://schemas.microsoft.com/office/drawing/2014/main" id="{DE30E863-D0D0-4377-C41B-91121E1B5522}"/>
               </a:ext>
             </a:extLst>
           </p:cNvPr>
@@ -2118,7 +2118,7 @@
           <p:cNvPr id="4" name="Slide Number Placeholder 3">
             <a:extLst>
               <a:ext uri="{FF2B5EF4-FFF2-40B4-BE49-F238E27FC236}">
-                <a16:creationId xmlns:a16="http://schemas.microsoft.com/office/drawing/2014/main" xmlns="" id="{FCBC8810-A436-C43F-800E-33081CC9E3BF}"/>
+                <a16:creationId xmlns:a16="http://schemas.microsoft.com/office/drawing/2014/main" id="{FCBC8810-A436-C43F-800E-33081CC9E3BF}"/>
               </a:ext>
             </a:extLst>
           </p:cNvPr>
@@ -2177,7 +2177,7 @@
           <p:cNvPr id="2" name="Title 1">
             <a:extLst>
               <a:ext uri="{FF2B5EF4-FFF2-40B4-BE49-F238E27FC236}">
-                <a16:creationId xmlns:a16="http://schemas.microsoft.com/office/drawing/2014/main" xmlns="" id="{48D5E12F-455A-9562-15D7-2C1236077737}"/>
+                <a16:creationId xmlns:a16="http://schemas.microsoft.com/office/drawing/2014/main" id="{48D5E12F-455A-9562-15D7-2C1236077737}"/>
               </a:ext>
             </a:extLst>
           </p:cNvPr>
@@ -2214,7 +2214,7 @@
           <p:cNvPr id="3" name="Content Placeholder 2">
             <a:extLst>
               <a:ext uri="{FF2B5EF4-FFF2-40B4-BE49-F238E27FC236}">
-                <a16:creationId xmlns:a16="http://schemas.microsoft.com/office/drawing/2014/main" xmlns="" id="{0CFAB899-56A5-0755-3342-C850480E0002}"/>
+                <a16:creationId xmlns:a16="http://schemas.microsoft.com/office/drawing/2014/main" id="{0CFAB899-56A5-0755-3342-C850480E0002}"/>
               </a:ext>
             </a:extLst>
           </p:cNvPr>
@@ -2304,7 +2304,7 @@
           <p:cNvPr id="4" name="Text Placeholder 3">
             <a:extLst>
               <a:ext uri="{FF2B5EF4-FFF2-40B4-BE49-F238E27FC236}">
-                <a16:creationId xmlns:a16="http://schemas.microsoft.com/office/drawing/2014/main" xmlns="" id="{0C57E362-0C7B-3BE2-3509-38267E74CA9F}"/>
+                <a16:creationId xmlns:a16="http://schemas.microsoft.com/office/drawing/2014/main" id="{0C57E362-0C7B-3BE2-3509-38267E74CA9F}"/>
               </a:ext>
             </a:extLst>
           </p:cNvPr>
@@ -2375,7 +2375,7 @@
           <p:cNvPr id="5" name="Date Placeholder 4">
             <a:extLst>
               <a:ext uri="{FF2B5EF4-FFF2-40B4-BE49-F238E27FC236}">
-                <a16:creationId xmlns:a16="http://schemas.microsoft.com/office/drawing/2014/main" xmlns="" id="{B2712F4B-6CF9-CA49-18B8-2801E8CC28D9}"/>
+                <a16:creationId xmlns:a16="http://schemas.microsoft.com/office/drawing/2014/main" id="{B2712F4B-6CF9-CA49-18B8-2801E8CC28D9}"/>
               </a:ext>
             </a:extLst>
           </p:cNvPr>
@@ -2404,7 +2404,7 @@
           <p:cNvPr id="6" name="Footer Placeholder 5">
             <a:extLst>
               <a:ext uri="{FF2B5EF4-FFF2-40B4-BE49-F238E27FC236}">
-                <a16:creationId xmlns:a16="http://schemas.microsoft.com/office/drawing/2014/main" xmlns="" id="{F9FC51EF-C0DF-F9D1-5634-C4E81B5B7AC8}"/>
+                <a16:creationId xmlns:a16="http://schemas.microsoft.com/office/drawing/2014/main" id="{F9FC51EF-C0DF-F9D1-5634-C4E81B5B7AC8}"/>
               </a:ext>
             </a:extLst>
           </p:cNvPr>
@@ -2429,7 +2429,7 @@
           <p:cNvPr id="7" name="Slide Number Placeholder 6">
             <a:extLst>
               <a:ext uri="{FF2B5EF4-FFF2-40B4-BE49-F238E27FC236}">
-                <a16:creationId xmlns:a16="http://schemas.microsoft.com/office/drawing/2014/main" xmlns="" id="{DE2E7A44-C576-8C8A-970F-28098F41BD47}"/>
+                <a16:creationId xmlns:a16="http://schemas.microsoft.com/office/drawing/2014/main" id="{DE2E7A44-C576-8C8A-970F-28098F41BD47}"/>
               </a:ext>
             </a:extLst>
           </p:cNvPr>
@@ -2488,7 +2488,7 @@
           <p:cNvPr id="2" name="Title 1">
             <a:extLst>
               <a:ext uri="{FF2B5EF4-FFF2-40B4-BE49-F238E27FC236}">
-                <a16:creationId xmlns:a16="http://schemas.microsoft.com/office/drawing/2014/main" xmlns="" id="{C3D3112C-36C8-EFBC-C401-E0F161F44461}"/>
+                <a16:creationId xmlns:a16="http://schemas.microsoft.com/office/drawing/2014/main" id="{C3D3112C-36C8-EFBC-C401-E0F161F44461}"/>
               </a:ext>
             </a:extLst>
           </p:cNvPr>
@@ -2525,7 +2525,7 @@
           <p:cNvPr id="3" name="Picture Placeholder 2">
             <a:extLst>
               <a:ext uri="{FF2B5EF4-FFF2-40B4-BE49-F238E27FC236}">
-                <a16:creationId xmlns:a16="http://schemas.microsoft.com/office/drawing/2014/main" xmlns="" id="{6F10467D-E165-7AC8-273C-B1AB54FBFCA8}"/>
+                <a16:creationId xmlns:a16="http://schemas.microsoft.com/office/drawing/2014/main" id="{6F10467D-E165-7AC8-273C-B1AB54FBFCA8}"/>
               </a:ext>
             </a:extLst>
           </p:cNvPr>
@@ -2592,7 +2592,7 @@
           <p:cNvPr id="4" name="Text Placeholder 3">
             <a:extLst>
               <a:ext uri="{FF2B5EF4-FFF2-40B4-BE49-F238E27FC236}">
-                <a16:creationId xmlns:a16="http://schemas.microsoft.com/office/drawing/2014/main" xmlns="" id="{8C60142D-8886-B0D6-0E5E-EB666D1DB450}"/>
+                <a16:creationId xmlns:a16="http://schemas.microsoft.com/office/drawing/2014/main" id="{8C60142D-8886-B0D6-0E5E-EB666D1DB450}"/>
               </a:ext>
             </a:extLst>
           </p:cNvPr>
@@ -2663,7 +2663,7 @@
           <p:cNvPr id="5" name="Date Placeholder 4">
             <a:extLst>
               <a:ext uri="{FF2B5EF4-FFF2-40B4-BE49-F238E27FC236}">
-                <a16:creationId xmlns:a16="http://schemas.microsoft.com/office/drawing/2014/main" xmlns="" id="{F12D38EB-DD4C-3DDE-9F52-693EC7B7FA7B}"/>
+                <a16:creationId xmlns:a16="http://schemas.microsoft.com/office/drawing/2014/main" id="{F12D38EB-DD4C-3DDE-9F52-693EC7B7FA7B}"/>
               </a:ext>
             </a:extLst>
           </p:cNvPr>
@@ -2692,7 +2692,7 @@
           <p:cNvPr id="6" name="Footer Placeholder 5">
             <a:extLst>
               <a:ext uri="{FF2B5EF4-FFF2-40B4-BE49-F238E27FC236}">
-                <a16:creationId xmlns:a16="http://schemas.microsoft.com/office/drawing/2014/main" xmlns="" id="{99DBB5D7-6F39-5A5D-529F-FE45C1CFA149}"/>
+                <a16:creationId xmlns:a16="http://schemas.microsoft.com/office/drawing/2014/main" id="{99DBB5D7-6F39-5A5D-529F-FE45C1CFA149}"/>
               </a:ext>
             </a:extLst>
           </p:cNvPr>
@@ -2717,7 +2717,7 @@
           <p:cNvPr id="7" name="Slide Number Placeholder 6">
             <a:extLst>
               <a:ext uri="{FF2B5EF4-FFF2-40B4-BE49-F238E27FC236}">
-                <a16:creationId xmlns:a16="http://schemas.microsoft.com/office/drawing/2014/main" xmlns="" id="{329A4A13-FC19-A055-26ED-AAD20E0F25EE}"/>
+                <a16:creationId xmlns:a16="http://schemas.microsoft.com/office/drawing/2014/main" id="{329A4A13-FC19-A055-26ED-AAD20E0F25EE}"/>
               </a:ext>
             </a:extLst>
           </p:cNvPr>
@@ -2812,7 +2812,7 @@
           <p:cNvPr id="2" name="Title Placeholder 1">
             <a:extLst>
               <a:ext uri="{FF2B5EF4-FFF2-40B4-BE49-F238E27FC236}">
-                <a16:creationId xmlns:a16="http://schemas.microsoft.com/office/drawing/2014/main" xmlns="" id="{319A5A2E-5446-3E57-10A4-C77E541C9E3D}"/>
+                <a16:creationId xmlns:a16="http://schemas.microsoft.com/office/drawing/2014/main" id="{319A5A2E-5446-3E57-10A4-C77E541C9E3D}"/>
               </a:ext>
             </a:extLst>
           </p:cNvPr>
@@ -2850,7 +2850,7 @@
           <p:cNvPr id="3" name="Text Placeholder 2">
             <a:extLst>
               <a:ext uri="{FF2B5EF4-FFF2-40B4-BE49-F238E27FC236}">
-                <a16:creationId xmlns:a16="http://schemas.microsoft.com/office/drawing/2014/main" xmlns="" id="{FDF09C63-2FF9-8A66-970C-DF9CA1BBD016}"/>
+                <a16:creationId xmlns:a16="http://schemas.microsoft.com/office/drawing/2014/main" id="{FDF09C63-2FF9-8A66-970C-DF9CA1BBD016}"/>
               </a:ext>
             </a:extLst>
           </p:cNvPr>
@@ -2917,7 +2917,7 @@
           <p:cNvPr id="4" name="Date Placeholder 3">
             <a:extLst>
               <a:ext uri="{FF2B5EF4-FFF2-40B4-BE49-F238E27FC236}">
-                <a16:creationId xmlns:a16="http://schemas.microsoft.com/office/drawing/2014/main" xmlns="" id="{E94816DA-1425-63F7-01D6-3A0BA5362A11}"/>
+                <a16:creationId xmlns:a16="http://schemas.microsoft.com/office/drawing/2014/main" id="{E94816DA-1425-63F7-01D6-3A0BA5362A11}"/>
               </a:ext>
             </a:extLst>
           </p:cNvPr>
@@ -2964,7 +2964,7 @@
           <p:cNvPr id="5" name="Footer Placeholder 4">
             <a:extLst>
               <a:ext uri="{FF2B5EF4-FFF2-40B4-BE49-F238E27FC236}">
-                <a16:creationId xmlns:a16="http://schemas.microsoft.com/office/drawing/2014/main" xmlns="" id="{A57BB893-3852-DD1D-A19D-F42CA0626F87}"/>
+                <a16:creationId xmlns:a16="http://schemas.microsoft.com/office/drawing/2014/main" id="{A57BB893-3852-DD1D-A19D-F42CA0626F87}"/>
               </a:ext>
             </a:extLst>
           </p:cNvPr>
@@ -3007,7 +3007,7 @@
           <p:cNvPr id="6" name="Slide Number Placeholder 5">
             <a:extLst>
               <a:ext uri="{FF2B5EF4-FFF2-40B4-BE49-F238E27FC236}">
-                <a16:creationId xmlns:a16="http://schemas.microsoft.com/office/drawing/2014/main" xmlns="" id="{84483858-41BF-DC7B-4606-1C6C62DD615F}"/>
+                <a16:creationId xmlns:a16="http://schemas.microsoft.com/office/drawing/2014/main" id="{84483858-41BF-DC7B-4606-1C6C62DD615F}"/>
               </a:ext>
             </a:extLst>
           </p:cNvPr>
@@ -3375,7 +3375,7 @@
           <p:cNvPr id="2" name="Title 1">
             <a:extLst>
               <a:ext uri="{FF2B5EF4-FFF2-40B4-BE49-F238E27FC236}">
-                <a16:creationId xmlns:a16="http://schemas.microsoft.com/office/drawing/2014/main" xmlns="" id="{C79CA116-0403-A58E-2705-BBC572BF5C41}"/>
+                <a16:creationId xmlns:a16="http://schemas.microsoft.com/office/drawing/2014/main" id="{C79CA116-0403-A58E-2705-BBC572BF5C41}"/>
               </a:ext>
             </a:extLst>
           </p:cNvPr>
@@ -3419,7 +3419,7 @@
           <p:cNvPr id="3" name="Subtitle 2">
             <a:extLst>
               <a:ext uri="{FF2B5EF4-FFF2-40B4-BE49-F238E27FC236}">
-                <a16:creationId xmlns:a16="http://schemas.microsoft.com/office/drawing/2014/main" xmlns="" id="{5E2F5AE3-A223-1DBE-FF88-640136681843}"/>
+                <a16:creationId xmlns:a16="http://schemas.microsoft.com/office/drawing/2014/main" id="{5E2F5AE3-A223-1DBE-FF88-640136681843}"/>
               </a:ext>
             </a:extLst>
           </p:cNvPr>
@@ -3483,6 +3483,116 @@
           </a:p>
           <a:p>
             <a:endParaRPr lang="en-US" dirty="0"/>
+          </a:p>
+        </p:txBody>
+      </p:sp>
+      <p:pic>
+        <p:nvPicPr>
+          <p:cNvPr id="7" name="Picture 6">
+            <a:extLst>
+              <a:ext uri="{FF2B5EF4-FFF2-40B4-BE49-F238E27FC236}">
+                <a16:creationId xmlns:a16="http://schemas.microsoft.com/office/drawing/2014/main" id="{E1FDDD99-9BF0-71D4-E87D-564B84CEAF63}"/>
+              </a:ext>
+            </a:extLst>
+          </p:cNvPr>
+          <p:cNvPicPr>
+            <a:picLocks noChangeAspect="1"/>
+          </p:cNvPicPr>
+          <p:nvPr/>
+        </p:nvPicPr>
+        <p:blipFill>
+          <a:blip r:embed="rId2">
+            <a:extLst>
+              <a:ext uri="{28A0092B-C50C-407E-A947-70E740481C1C}">
+                <a14:useLocalDpi xmlns:a14="http://schemas.microsoft.com/office/drawing/2010/main" val="0"/>
+              </a:ext>
+              <a:ext uri="{837473B0-CC2E-450A-ABE3-18F120FF3D39}">
+                <a1611:picAttrSrcUrl xmlns:a1611="http://schemas.microsoft.com/office/drawing/2016/11/main" r:id="rId3"/>
+              </a:ext>
+            </a:extLst>
+          </a:blip>
+          <a:stretch>
+            <a:fillRect/>
+          </a:stretch>
+        </p:blipFill>
+        <p:spPr>
+          <a:xfrm>
+            <a:off x="0" y="2471057"/>
+            <a:ext cx="2763818" cy="1730150"/>
+          </a:xfrm>
+          <a:prstGeom prst="ellipse">
+            <a:avLst/>
+          </a:prstGeom>
+          <a:ln w="190500" cap="rnd">
+            <a:noFill/>
+            <a:prstDash val="solid"/>
+          </a:ln>
+          <a:effectLst>
+            <a:outerShdw blurRad="184150" dist="241300" dir="11520000" sx="110000" sy="110000" algn="ctr">
+              <a:srgbClr val="000000">
+                <a:alpha val="18000"/>
+              </a:srgbClr>
+            </a:outerShdw>
+          </a:effectLst>
+          <a:scene3d>
+            <a:camera prst="perspectiveFront" fov="5100000">
+              <a:rot lat="0" lon="2100000" rev="0"/>
+            </a:camera>
+            <a:lightRig rig="flood" dir="t">
+              <a:rot lat="0" lon="0" rev="13800000"/>
+            </a:lightRig>
+          </a:scene3d>
+          <a:sp3d extrusionH="107950" prstMaterial="plastic">
+            <a:bevelT w="82550" h="63500" prst="divot"/>
+            <a:bevelB/>
+          </a:sp3d>
+        </p:spPr>
+      </p:pic>
+      <p:sp>
+        <p:nvSpPr>
+          <p:cNvPr id="8" name="TextBox 7">
+            <a:extLst>
+              <a:ext uri="{FF2B5EF4-FFF2-40B4-BE49-F238E27FC236}">
+                <a16:creationId xmlns:a16="http://schemas.microsoft.com/office/drawing/2014/main" id="{2873BA6A-3FFF-9930-34EC-D5129CF56BF9}"/>
+              </a:ext>
+            </a:extLst>
+          </p:cNvPr>
+          <p:cNvSpPr txBox="1"/>
+          <p:nvPr/>
+        </p:nvSpPr>
+        <p:spPr>
+          <a:xfrm>
+            <a:off x="1067121" y="7010400"/>
+            <a:ext cx="1774050" cy="369332"/>
+          </a:xfrm>
+          <a:prstGeom prst="rect">
+            <a:avLst/>
+          </a:prstGeom>
+          <a:noFill/>
+        </p:spPr>
+        <p:txBody>
+          <a:bodyPr wrap="square" rtlCol="0">
+            <a:spAutoFit/>
+          </a:bodyPr>
+          <a:lstStyle/>
+          <a:p>
+            <a:r>
+              <a:rPr lang="en-US" sz="900">
+                <a:hlinkClick r:id="rId3" tooltip="https://www.flickr.com/photos/gozalewis/4565833940/"/>
+              </a:rPr>
+              <a:t>This Photo</a:t>
+            </a:r>
+            <a:r>
+              <a:rPr lang="en-US" sz="900"/>
+              <a:t> by Unknown Author is licensed under </a:t>
+            </a:r>
+            <a:r>
+              <a:rPr lang="en-US" sz="900">
+                <a:hlinkClick r:id="rId4" tooltip="https://creativecommons.org/licenses/by-sa/3.0/"/>
+              </a:rPr>
+              <a:t>CC BY-SA</a:t>
+            </a:r>
+            <a:endParaRPr lang="en-US" sz="900"/>
           </a:p>
         </p:txBody>
       </p:sp>
@@ -3533,15 +3643,19 @@
           </a:xfrm>
         </p:spPr>
         <p:txBody>
-          <a:bodyPr/>
+          <a:bodyPr>
+            <a:noAutofit/>
+          </a:bodyPr>
           <a:lstStyle/>
           <a:p>
             <a:pPr algn="ctr"/>
             <a:r>
-              <a:rPr lang="en-US" b="1" dirty="0" smtClean="0"/>
+              <a:rPr lang="en-US" sz="3600" b="1" dirty="0">
+                <a:latin typeface="Times New Roman" panose="02020603050405020304" pitchFamily="18" charset="0"/>
+                <a:cs typeface="Times New Roman" panose="02020603050405020304" pitchFamily="18" charset="0"/>
+              </a:rPr>
               <a:t>FLOWCHART FOR SINGLE PLAYER GAMEPLAY</a:t>
             </a:r>
-            <a:endParaRPr lang="en-US" b="1" dirty="0"/>
           </a:p>
         </p:txBody>
       </p:sp>
@@ -3617,7 +3731,7 @@
                 <a:spcPct val="0"/>
               </a:spcAft>
             </a:pPr>
-            <a:endParaRPr kumimoji="0" lang="en-US" sz="1800" i="0" u="none" strike="noStrike" cap="none" normalizeH="0" baseline="0" dirty="0" smtClean="0">
+            <a:endParaRPr kumimoji="0" lang="en-US" sz="1800" i="0" u="none" strike="noStrike" cap="none" normalizeH="0" baseline="0" dirty="0">
               <a:ln>
                 <a:noFill/>
               </a:ln>
@@ -3656,7 +3770,7 @@
                 <a:spcPct val="0"/>
               </a:spcAft>
             </a:pPr>
-            <a:endParaRPr kumimoji="0" lang="en-US" sz="1800" i="0" u="none" strike="noStrike" cap="none" normalizeH="0" baseline="0" dirty="0" smtClean="0">
+            <a:endParaRPr kumimoji="0" lang="en-US" sz="1800" i="0" u="none" strike="noStrike" cap="none" normalizeH="0" baseline="0" dirty="0">
               <a:ln>
                 <a:noFill/>
               </a:ln>
@@ -3695,7 +3809,7 @@
                 <a:spcPct val="0"/>
               </a:spcAft>
             </a:pPr>
-            <a:endParaRPr kumimoji="0" lang="en-US" sz="1800" i="0" u="none" strike="noStrike" cap="none" normalizeH="0" baseline="0" dirty="0" smtClean="0">
+            <a:endParaRPr kumimoji="0" lang="en-US" sz="1800" i="0" u="none" strike="noStrike" cap="none" normalizeH="0" baseline="0" dirty="0">
               <a:ln>
                 <a:noFill/>
               </a:ln>
@@ -3734,7 +3848,7 @@
                 <a:spcPct val="0"/>
               </a:spcAft>
             </a:pPr>
-            <a:endParaRPr kumimoji="0" lang="en-US" sz="1800" i="0" u="none" strike="noStrike" cap="none" normalizeH="0" baseline="0" dirty="0" smtClean="0">
+            <a:endParaRPr kumimoji="0" lang="en-US" sz="1800" i="0" u="none" strike="noStrike" cap="none" normalizeH="0" baseline="0" dirty="0">
               <a:ln>
                 <a:noFill/>
               </a:ln>
@@ -3773,7 +3887,7 @@
                 <a:spcPct val="0"/>
               </a:spcAft>
             </a:pPr>
-            <a:endParaRPr kumimoji="0" lang="en-US" sz="1800" i="0" u="none" strike="noStrike" cap="none" normalizeH="0" baseline="0" dirty="0" smtClean="0">
+            <a:endParaRPr kumimoji="0" lang="en-US" sz="1800" i="0" u="none" strike="noStrike" cap="none" normalizeH="0" baseline="0" dirty="0">
               <a:ln>
                 <a:noFill/>
               </a:ln>
@@ -3812,7 +3926,7 @@
                 <a:spcPct val="0"/>
               </a:spcAft>
             </a:pPr>
-            <a:endParaRPr kumimoji="0" lang="en-US" sz="1800" i="0" u="none" strike="noStrike" cap="none" normalizeH="0" baseline="0" dirty="0" smtClean="0">
+            <a:endParaRPr kumimoji="0" lang="en-US" sz="1800" i="0" u="none" strike="noStrike" cap="none" normalizeH="0" baseline="0" dirty="0">
               <a:ln>
                 <a:noFill/>
               </a:ln>
@@ -3851,7 +3965,7 @@
                 <a:spcPct val="0"/>
               </a:spcAft>
             </a:pPr>
-            <a:endParaRPr kumimoji="0" lang="en-US" sz="1800" i="0" u="none" strike="noStrike" cap="none" normalizeH="0" baseline="0" dirty="0" smtClean="0">
+            <a:endParaRPr kumimoji="0" lang="en-US" sz="1800" i="0" u="none" strike="noStrike" cap="none" normalizeH="0" baseline="0" dirty="0">
               <a:ln>
                 <a:noFill/>
               </a:ln>
@@ -3890,7 +4004,7 @@
                 <a:spcPct val="0"/>
               </a:spcAft>
             </a:pPr>
-            <a:endParaRPr kumimoji="0" lang="en-US" sz="1800" i="0" u="none" strike="noStrike" cap="none" normalizeH="0" baseline="0" dirty="0" smtClean="0">
+            <a:endParaRPr kumimoji="0" lang="en-US" sz="1800" i="0" u="none" strike="noStrike" cap="none" normalizeH="0" baseline="0" dirty="0">
               <a:ln>
                 <a:noFill/>
               </a:ln>
@@ -3929,7 +4043,7 @@
                 <a:spcPct val="0"/>
               </a:spcAft>
             </a:pPr>
-            <a:endParaRPr kumimoji="0" lang="en-US" sz="1800" i="0" u="none" strike="noStrike" cap="none" normalizeH="0" baseline="0" dirty="0" smtClean="0">
+            <a:endParaRPr kumimoji="0" lang="en-US" sz="1800" i="0" u="none" strike="noStrike" cap="none" normalizeH="0" baseline="0" dirty="0">
               <a:ln>
                 <a:noFill/>
               </a:ln>
@@ -3968,7 +4082,7 @@
                 <a:spcPct val="0"/>
               </a:spcAft>
             </a:pPr>
-            <a:endParaRPr kumimoji="0" lang="en-US" sz="1800" i="0" u="none" strike="noStrike" cap="none" normalizeH="0" baseline="0" dirty="0" smtClean="0">
+            <a:endParaRPr kumimoji="0" lang="en-US" sz="1800" i="0" u="none" strike="noStrike" cap="none" normalizeH="0" baseline="0" dirty="0">
               <a:ln>
                 <a:noFill/>
               </a:ln>
@@ -3991,7 +4105,7 @@
                 <a:spcPct val="0"/>
               </a:spcAft>
             </a:pPr>
-            <a:endParaRPr lang="en-US" sz="1800" dirty="0" smtClean="0">
+            <a:endParaRPr lang="en-US" sz="1800" dirty="0">
               <a:latin typeface="Arial" panose="020B0604020202020204" pitchFamily="34" charset="0"/>
             </a:endParaRPr>
           </a:p>
@@ -4024,7 +4138,7 @@
               </a:spcAft>
             </a:pPr>
             <a:r>
-              <a:rPr kumimoji="0" lang="en-US" sz="1800" i="0" u="none" strike="noStrike" cap="none" normalizeH="0" baseline="0" dirty="0" smtClean="0">
+              <a:rPr kumimoji="0" lang="en-US" sz="1800" i="0" u="none" strike="noStrike" cap="none" normalizeH="0" baseline="0" dirty="0">
                 <a:ln>
                   <a:noFill/>
                 </a:ln>
@@ -4059,8 +4173,8 @@
         </p:blipFill>
         <p:spPr>
           <a:xfrm>
-            <a:off x="2267583" y="771526"/>
-            <a:ext cx="6895467" cy="5657215"/>
+            <a:off x="2267583" y="1153886"/>
+            <a:ext cx="6895467" cy="5274855"/>
           </a:xfrm>
           <a:prstGeom prst="rect">
             <a:avLst/>
@@ -4117,11 +4231,14 @@
           <a:bodyPr/>
           <a:lstStyle/>
           <a:p>
-            <a:r>
-              <a:rPr lang="en-US" b="1" dirty="0" smtClean="0"/>
+            <a:pPr algn="ctr"/>
+            <a:r>
+              <a:rPr lang="en-US" b="1" dirty="0">
+                <a:latin typeface="Times New Roman" panose="02020603050405020304" pitchFamily="18" charset="0"/>
+                <a:cs typeface="Times New Roman" panose="02020603050405020304" pitchFamily="18" charset="0"/>
+              </a:rPr>
               <a:t>FLOWCHART FOR MULTIPLAYER GAMEPLAY</a:t>
             </a:r>
-            <a:endParaRPr lang="en-US" b="1" dirty="0"/>
           </a:p>
         </p:txBody>
       </p:sp>
@@ -4147,40 +4264,40 @@
           </a:bodyPr>
           <a:lstStyle/>
           <a:p>
-            <a:endParaRPr lang="en-US" dirty="0" smtClean="0"/>
-          </a:p>
-          <a:p>
             <a:endParaRPr lang="en-US" dirty="0"/>
           </a:p>
           <a:p>
-            <a:endParaRPr lang="en-US" dirty="0" smtClean="0"/>
-          </a:p>
-          <a:p>
             <a:endParaRPr lang="en-US" dirty="0"/>
           </a:p>
           <a:p>
-            <a:endParaRPr lang="en-US" dirty="0" smtClean="0"/>
-          </a:p>
-          <a:p>
             <a:endParaRPr lang="en-US" dirty="0"/>
           </a:p>
           <a:p>
-            <a:endParaRPr lang="en-US" dirty="0" smtClean="0"/>
-          </a:p>
-          <a:p>
             <a:endParaRPr lang="en-US" dirty="0"/>
           </a:p>
           <a:p>
-            <a:endParaRPr lang="en-US" dirty="0" smtClean="0"/>
-          </a:p>
-          <a:p>
             <a:endParaRPr lang="en-US" dirty="0"/>
           </a:p>
           <a:p>
+            <a:endParaRPr lang="en-US" dirty="0"/>
+          </a:p>
+          <a:p>
+            <a:endParaRPr lang="en-US" dirty="0"/>
+          </a:p>
+          <a:p>
+            <a:endParaRPr lang="en-US" dirty="0"/>
+          </a:p>
+          <a:p>
+            <a:endParaRPr lang="en-US" dirty="0"/>
+          </a:p>
+          <a:p>
+            <a:endParaRPr lang="en-US" dirty="0"/>
+          </a:p>
+          <a:p>
             <a:pPr marL="0" indent="0">
               <a:buNone/>
             </a:pPr>
-            <a:endParaRPr lang="en-US" dirty="0" smtClean="0"/>
+            <a:endParaRPr lang="en-US" dirty="0"/>
           </a:p>
           <a:p>
             <a:pPr marL="0" indent="0">
@@ -4192,13 +4309,13 @@
             <a:pPr marL="0" indent="0">
               <a:buNone/>
             </a:pPr>
-            <a:endParaRPr lang="en-US" dirty="0" smtClean="0"/>
+            <a:endParaRPr lang="en-US" dirty="0"/>
           </a:p>
           <a:p>
             <a:pPr marL="0" indent="0">
               <a:buNone/>
             </a:pPr>
-            <a:endParaRPr lang="en-US" dirty="0" smtClean="0"/>
+            <a:endParaRPr lang="en-US" dirty="0"/>
           </a:p>
           <a:p>
             <a:pPr marL="0" indent="0">
@@ -4214,12 +4331,8 @@
           </a:p>
           <a:p>
             <a:r>
-              <a:rPr lang="en-US" dirty="0" smtClean="0"/>
-              <a:t>Shows </a:t>
-            </a:r>
-            <a:r>
               <a:rPr lang="en-US" dirty="0"/>
-              <a:t>the gameplay process between two registered players and the result generation</a:t>
+              <a:t>Shows the gameplay process between two registered players and the result generation</a:t>
             </a:r>
           </a:p>
         </p:txBody>
@@ -4300,15 +4413,18 @@
         </p:spPr>
         <p:txBody>
           <a:bodyPr>
-            <a:normAutofit/>
+            <a:normAutofit fontScale="90000"/>
           </a:bodyPr>
           <a:lstStyle/>
           <a:p>
-            <a:r>
-              <a:rPr lang="en-US" sz="3600" b="1" dirty="0" smtClean="0"/>
+            <a:pPr algn="ctr"/>
+            <a:r>
+              <a:rPr lang="en-US" sz="3600" b="1" dirty="0">
+                <a:latin typeface="Times New Roman" panose="02020603050405020304" pitchFamily="18" charset="0"/>
+                <a:cs typeface="Times New Roman" panose="02020603050405020304" pitchFamily="18" charset="0"/>
+              </a:rPr>
               <a:t>FLOWCHART FOR HISTORY, LEADERBOARD AND DELETE</a:t>
             </a:r>
-            <a:endParaRPr lang="en-US" sz="3600" b="1" dirty="0"/>
           </a:p>
         </p:txBody>
       </p:sp>
@@ -4334,57 +4450,45 @@
           </a:bodyPr>
           <a:lstStyle/>
           <a:p>
-            <a:endParaRPr lang="en-US" dirty="0" smtClean="0"/>
-          </a:p>
-          <a:p>
             <a:endParaRPr lang="en-US" dirty="0"/>
           </a:p>
           <a:p>
-            <a:endParaRPr lang="en-US" dirty="0" smtClean="0"/>
-          </a:p>
-          <a:p>
             <a:endParaRPr lang="en-US" dirty="0"/>
           </a:p>
           <a:p>
-            <a:endParaRPr lang="en-US" dirty="0" smtClean="0"/>
-          </a:p>
-          <a:p>
             <a:endParaRPr lang="en-US" dirty="0"/>
           </a:p>
           <a:p>
-            <a:endParaRPr lang="en-US" dirty="0" smtClean="0"/>
-          </a:p>
-          <a:p>
             <a:endParaRPr lang="en-US" dirty="0"/>
           </a:p>
           <a:p>
-            <a:endParaRPr lang="en-US" dirty="0" smtClean="0"/>
-          </a:p>
-          <a:p>
-            <a:endParaRPr lang="en-US" dirty="0" smtClean="0"/>
-          </a:p>
-          <a:p>
             <a:endParaRPr lang="en-US" dirty="0"/>
           </a:p>
           <a:p>
-            <a:endParaRPr lang="en-US" dirty="0" smtClean="0"/>
-          </a:p>
-          <a:p>
-            <a:r>
-              <a:rPr lang="en-US" sz="2400" dirty="0" smtClean="0"/>
-              <a:t>Illustrates </a:t>
-            </a:r>
+            <a:endParaRPr lang="en-US" dirty="0"/>
+          </a:p>
+          <a:p>
+            <a:endParaRPr lang="en-US" dirty="0"/>
+          </a:p>
+          <a:p>
+            <a:endParaRPr lang="en-US" dirty="0"/>
+          </a:p>
+          <a:p>
+            <a:endParaRPr lang="en-US" dirty="0"/>
+          </a:p>
+          <a:p>
+            <a:endParaRPr lang="en-US" dirty="0"/>
+          </a:p>
+          <a:p>
+            <a:endParaRPr lang="en-US" dirty="0"/>
+          </a:p>
+          <a:p>
+            <a:endParaRPr lang="en-US" dirty="0"/>
+          </a:p>
+          <a:p>
             <a:r>
               <a:rPr lang="en-US" sz="2400" dirty="0"/>
-              <a:t>the process of viewing match history, leaderboard, and deleting a </a:t>
-            </a:r>
-            <a:r>
-              <a:rPr lang="en-US" sz="2400" dirty="0" smtClean="0"/>
-              <a:t>user account</a:t>
-            </a:r>
-            <a:r>
-              <a:rPr lang="en-US" sz="2400" dirty="0"/>
-              <a:t>.</a:t>
+              <a:t>Illustrates the process of viewing match history, leaderboard, and deleting a user account.</a:t>
             </a:r>
           </a:p>
         </p:txBody>
@@ -4409,8 +4513,8 @@
         </p:blipFill>
         <p:spPr>
           <a:xfrm>
-            <a:off x="914400" y="795019"/>
-            <a:ext cx="10287000" cy="5539105"/>
+            <a:off x="957943" y="925286"/>
+            <a:ext cx="10134599" cy="5221514"/>
           </a:xfrm>
           <a:prstGeom prst="rect">
             <a:avLst/>
@@ -4469,10 +4573,12 @@
           <a:p>
             <a:pPr algn="ctr"/>
             <a:r>
-              <a:rPr lang="en-US" b="1" dirty="0" smtClean="0"/>
+              <a:rPr lang="en-US" b="1" dirty="0">
+                <a:latin typeface="Times New Roman" panose="02020603050405020304" pitchFamily="18" charset="0"/>
+                <a:cs typeface="Times New Roman" panose="02020603050405020304" pitchFamily="18" charset="0"/>
+              </a:rPr>
               <a:t>USE CASE DIAGRAM</a:t>
             </a:r>
-            <a:endParaRPr lang="en-US" b="1" dirty="0"/>
           </a:p>
         </p:txBody>
       </p:sp>
@@ -4498,55 +4604,51 @@
           </a:bodyPr>
           <a:lstStyle/>
           <a:p>
-            <a:endParaRPr lang="en-US" sz="2000" dirty="0" smtClean="0"/>
-          </a:p>
-          <a:p>
             <a:endParaRPr lang="en-US" sz="2000" dirty="0"/>
           </a:p>
           <a:p>
-            <a:endParaRPr lang="en-US" sz="2000" dirty="0" smtClean="0"/>
-          </a:p>
-          <a:p>
             <a:endParaRPr lang="en-US" sz="2000" dirty="0"/>
           </a:p>
           <a:p>
-            <a:endParaRPr lang="en-US" sz="2000" dirty="0" smtClean="0"/>
-          </a:p>
-          <a:p>
             <a:endParaRPr lang="en-US" sz="2000" dirty="0"/>
           </a:p>
           <a:p>
-            <a:endParaRPr lang="en-US" sz="2000" dirty="0" smtClean="0"/>
-          </a:p>
-          <a:p>
             <a:endParaRPr lang="en-US" sz="2000" dirty="0"/>
           </a:p>
           <a:p>
-            <a:endParaRPr lang="en-US" sz="2000" dirty="0" smtClean="0"/>
-          </a:p>
-          <a:p>
             <a:endParaRPr lang="en-US" sz="2000" dirty="0"/>
           </a:p>
           <a:p>
-            <a:endParaRPr lang="en-US" sz="2000" dirty="0" smtClean="0"/>
-          </a:p>
-          <a:p>
             <a:endParaRPr lang="en-US" sz="2000" dirty="0"/>
           </a:p>
           <a:p>
-            <a:endParaRPr lang="en-US" sz="2000" dirty="0" smtClean="0"/>
-          </a:p>
-          <a:p>
-            <a:endParaRPr lang="en-US" sz="2000" dirty="0" smtClean="0"/>
-          </a:p>
-          <a:p>
-            <a:r>
-              <a:rPr lang="en-US" sz="2000" dirty="0" smtClean="0"/>
-              <a:t>The </a:t>
-            </a:r>
+            <a:endParaRPr lang="en-US" sz="2000" dirty="0"/>
+          </a:p>
+          <a:p>
+            <a:endParaRPr lang="en-US" sz="2000" dirty="0"/>
+          </a:p>
+          <a:p>
+            <a:endParaRPr lang="en-US" sz="2000" dirty="0"/>
+          </a:p>
+          <a:p>
+            <a:endParaRPr lang="en-US" sz="2000" dirty="0"/>
+          </a:p>
+          <a:p>
+            <a:endParaRPr lang="en-US" sz="2000" dirty="0"/>
+          </a:p>
+          <a:p>
+            <a:endParaRPr lang="en-US" sz="2000" dirty="0"/>
+          </a:p>
+          <a:p>
+            <a:endParaRPr lang="en-US" sz="2000" dirty="0"/>
+          </a:p>
+          <a:p>
+            <a:endParaRPr lang="en-US" sz="2000" dirty="0"/>
+          </a:p>
+          <a:p>
             <a:r>
               <a:rPr lang="en-US" sz="2000" dirty="0"/>
-              <a:t>Use Case Diagram provides an overview of the system's functional requirements and shows how the user interacts with the different features of the application.</a:t>
+              <a:t>The Use Case Diagram provides an overview of the system's functional requirements and shows how the user interacts with the different features of the application.</a:t>
             </a:r>
           </a:p>
         </p:txBody>
@@ -4630,10 +4732,12 @@
           <a:p>
             <a:pPr algn="ctr"/>
             <a:r>
-              <a:rPr lang="en-US" sz="6000" b="1" dirty="0" smtClean="0"/>
+              <a:rPr lang="en-US" b="1" dirty="0">
+                <a:latin typeface="Times New Roman" panose="02020603050405020304" pitchFamily="18" charset="0"/>
+                <a:cs typeface="Times New Roman" panose="02020603050405020304" pitchFamily="18" charset="0"/>
+              </a:rPr>
               <a:t>CONCLUSION</a:t>
             </a:r>
-            <a:endParaRPr lang="en-US" sz="6000" b="1" dirty="0"/>
           </a:p>
         </p:txBody>
       </p:sp>
@@ -4664,10 +4768,12 @@
               <a:buAutoNum type="arabicPeriod"/>
             </a:pPr>
             <a:r>
-              <a:rPr lang="en-US" sz="2400" dirty="0"/>
+              <a:rPr lang="en-US" sz="2400" dirty="0">
+                <a:latin typeface="Times New Roman" panose="02020603050405020304" pitchFamily="18" charset="0"/>
+                <a:cs typeface="Times New Roman" panose="02020603050405020304" pitchFamily="18" charset="0"/>
+              </a:rPr>
               <a:t>The Rock Paper Scissors Game was successfully developed using the C programming language. </a:t>
             </a:r>
-            <a:endParaRPr lang="en-US" sz="2400" dirty="0" smtClean="0"/>
           </a:p>
           <a:p>
             <a:pPr marL="514350" indent="-514350">
@@ -4675,14 +4781,12 @@
               <a:buAutoNum type="arabicPeriod"/>
             </a:pPr>
             <a:r>
-              <a:rPr lang="en-US" sz="2400" dirty="0" smtClean="0"/>
-              <a:t>The </a:t>
-            </a:r>
-            <a:r>
-              <a:rPr lang="en-US" sz="2400" dirty="0"/>
-              <a:t>system provides user registration, login, single-player and multiplayer gameplay, leaderboard, and match history. </a:t>
-            </a:r>
-            <a:endParaRPr lang="en-US" sz="2400" dirty="0" smtClean="0"/>
+              <a:rPr lang="en-US" sz="2400" dirty="0">
+                <a:latin typeface="Times New Roman" panose="02020603050405020304" pitchFamily="18" charset="0"/>
+                <a:cs typeface="Times New Roman" panose="02020603050405020304" pitchFamily="18" charset="0"/>
+              </a:rPr>
+              <a:t>The system provides user registration, login, single-player and multiplayer gameplay, leaderboard, and match history. </a:t>
+            </a:r>
           </a:p>
           <a:p>
             <a:pPr marL="514350" indent="-514350">
@@ -4690,14 +4794,12 @@
               <a:buAutoNum type="arabicPeriod"/>
             </a:pPr>
             <a:r>
-              <a:rPr lang="en-US" sz="2400" dirty="0" smtClean="0"/>
-              <a:t>File </a:t>
-            </a:r>
-            <a:r>
-              <a:rPr lang="en-US" sz="2400" dirty="0"/>
-              <a:t>handling enables permanent storage of player records and game statistics. </a:t>
-            </a:r>
-            <a:endParaRPr lang="en-US" sz="2400" dirty="0" smtClean="0"/>
+              <a:rPr lang="en-US" sz="2400" dirty="0">
+                <a:latin typeface="Times New Roman" panose="02020603050405020304" pitchFamily="18" charset="0"/>
+                <a:cs typeface="Times New Roman" panose="02020603050405020304" pitchFamily="18" charset="0"/>
+              </a:rPr>
+              <a:t>File handling enables permanent storage of player records and game statistics. </a:t>
+            </a:r>
           </a:p>
           <a:p>
             <a:pPr marL="514350" indent="-514350">
@@ -4705,14 +4807,12 @@
               <a:buAutoNum type="arabicPeriod"/>
             </a:pPr>
             <a:r>
-              <a:rPr lang="en-US" sz="2400" dirty="0" smtClean="0"/>
-              <a:t>The </a:t>
-            </a:r>
-            <a:r>
-              <a:rPr lang="en-US" sz="2400" dirty="0"/>
-              <a:t>project enhanced our knowledge of programming, file handling, teamwork, and software development. </a:t>
-            </a:r>
-            <a:endParaRPr lang="en-US" sz="2400" dirty="0" smtClean="0"/>
+              <a:rPr lang="en-US" sz="2400" dirty="0">
+                <a:latin typeface="Times New Roman" panose="02020603050405020304" pitchFamily="18" charset="0"/>
+                <a:cs typeface="Times New Roman" panose="02020603050405020304" pitchFamily="18" charset="0"/>
+              </a:rPr>
+              <a:t>The project enhanced our knowledge of programming, file handling, teamwork, and software development. </a:t>
+            </a:r>
           </a:p>
           <a:p>
             <a:pPr marL="514350" indent="-514350">
@@ -4720,12 +4820,15 @@
               <a:buAutoNum type="arabicPeriod"/>
             </a:pPr>
             <a:r>
-              <a:rPr lang="en-US" sz="2400" dirty="0" smtClean="0"/>
-              <a:t>Overall</a:t>
+              <a:rPr lang="en-US" sz="2400" dirty="0">
+                <a:latin typeface="Times New Roman" panose="02020603050405020304" pitchFamily="18" charset="0"/>
+                <a:cs typeface="Times New Roman" panose="02020603050405020304" pitchFamily="18" charset="0"/>
+              </a:rPr>
+              <a:t>Overall, the project achieved its objectives and can be further enhanced with GUI, database integration, and online multiplayer features</a:t>
             </a:r>
             <a:r>
               <a:rPr lang="en-US" sz="2400" dirty="0"/>
-              <a:t>, the project achieved its objectives and can be further enhanced with GUI, database integration, and online multiplayer features. </a:t>
+              <a:t>. </a:t>
             </a:r>
           </a:p>
         </p:txBody>
@@ -4765,7 +4868,7 @@
           <p:cNvPr id="2" name="Title 1">
             <a:extLst>
               <a:ext uri="{FF2B5EF4-FFF2-40B4-BE49-F238E27FC236}">
-                <a16:creationId xmlns:a16="http://schemas.microsoft.com/office/drawing/2014/main" xmlns="" id="{B654934D-C094-BA3C-9DC7-69A3E5F4CEF4}"/>
+                <a16:creationId xmlns:a16="http://schemas.microsoft.com/office/drawing/2014/main" id="{B654934D-C094-BA3C-9DC7-69A3E5F4CEF4}"/>
               </a:ext>
             </a:extLst>
           </p:cNvPr>
@@ -4787,10 +4890,9 @@
           <a:lstStyle/>
           <a:p>
             <a:r>
-              <a:rPr lang="en-US" b="1" dirty="0" smtClean="0"/>
+              <a:rPr lang="en-US" b="1" dirty="0"/>
               <a:t>INTRODUCTION</a:t>
             </a:r>
-            <a:endParaRPr lang="en-US" b="1" dirty="0"/>
           </a:p>
         </p:txBody>
       </p:sp>
@@ -4799,7 +4901,7 @@
           <p:cNvPr id="3" name="Subtitle 2">
             <a:extLst>
               <a:ext uri="{FF2B5EF4-FFF2-40B4-BE49-F238E27FC236}">
-                <a16:creationId xmlns:a16="http://schemas.microsoft.com/office/drawing/2014/main" xmlns="" id="{F6E52F9D-8044-4BB7-A57D-CFC90EFB43A5}"/>
+                <a16:creationId xmlns:a16="http://schemas.microsoft.com/office/drawing/2014/main" id="{F6E52F9D-8044-4BB7-A57D-CFC90EFB43A5}"/>
               </a:ext>
             </a:extLst>
           </p:cNvPr>
@@ -4827,22 +4929,9 @@
               <a:buAutoNum type="arabicPeriod"/>
             </a:pPr>
             <a:r>
-              <a:rPr lang="en-US" dirty="0" smtClean="0"/>
-              <a:t>Rock </a:t>
-            </a:r>
-            <a:r>
               <a:rPr lang="en-US" dirty="0"/>
-              <a:t>Paper Scissors is a simple and popular hand game played between </a:t>
-            </a:r>
-            <a:r>
-              <a:rPr lang="en-US" dirty="0" smtClean="0"/>
-              <a:t>two </a:t>
-            </a:r>
-            <a:r>
-              <a:rPr lang="en-US" dirty="0"/>
-              <a:t>players. </a:t>
-            </a:r>
-            <a:endParaRPr lang="en-US" dirty="0" smtClean="0"/>
+              <a:t>Rock Paper Scissors is a simple and popular hand game played between two players. </a:t>
+            </a:r>
           </a:p>
           <a:p>
             <a:pPr marL="514350" indent="-514350" algn="l">
@@ -4850,24 +4939,8 @@
               <a:buAutoNum type="arabicPeriod"/>
             </a:pPr>
             <a:r>
-              <a:rPr lang="en-US" dirty="0" smtClean="0"/>
-              <a:t>This </a:t>
-            </a:r>
-            <a:r>
               <a:rPr lang="en-US" dirty="0"/>
-              <a:t>project develops a digital version of </a:t>
-            </a:r>
-            <a:r>
-              <a:rPr lang="en-US" dirty="0" smtClean="0"/>
-              <a:t>the </a:t>
-            </a:r>
-            <a:r>
-              <a:rPr lang="en-US" dirty="0"/>
-              <a:t>game using the C </a:t>
-            </a:r>
-            <a:r>
-              <a:rPr lang="en-US" dirty="0" smtClean="0"/>
-              <a:t>programming language.</a:t>
+              <a:t>This project develops a digital version of the game using the C programming language.</a:t>
             </a:r>
           </a:p>
           <a:p>
@@ -4876,14 +4949,9 @@
               <a:buAutoNum type="arabicPeriod"/>
             </a:pPr>
             <a:r>
-              <a:rPr lang="en-US" dirty="0" smtClean="0"/>
-              <a:t>The </a:t>
-            </a:r>
-            <a:r>
               <a:rPr lang="en-US" dirty="0"/>
-              <a:t>system provides user registration, login, single-player and multiplayer modes. </a:t>
-            </a:r>
-            <a:endParaRPr lang="en-US" dirty="0" smtClean="0"/>
+              <a:t>The system provides user registration, login, single-player and multiplayer modes. </a:t>
+            </a:r>
           </a:p>
           <a:p>
             <a:pPr marL="514350" indent="-514350" algn="l">
@@ -4891,14 +4959,9 @@
               <a:buAutoNum type="arabicPeriod"/>
             </a:pPr>
             <a:r>
-              <a:rPr lang="en-US" dirty="0" smtClean="0"/>
-              <a:t>It </a:t>
-            </a:r>
-            <a:r>
               <a:rPr lang="en-US" dirty="0"/>
-              <a:t>uses file handling to store player information, match history, and leaderboard records. </a:t>
-            </a:r>
-            <a:endParaRPr lang="en-US" dirty="0" smtClean="0"/>
+              <a:t>It uses file handling to store player information, match history, and leaderboard records. </a:t>
+            </a:r>
           </a:p>
           <a:p>
             <a:pPr marL="514350" indent="-514350" algn="l">
@@ -4906,12 +4969,8 @@
               <a:buAutoNum type="arabicPeriod"/>
             </a:pPr>
             <a:r>
-              <a:rPr lang="en-US" dirty="0" smtClean="0"/>
-              <a:t>The </a:t>
-            </a:r>
-            <a:r>
               <a:rPr lang="en-US" dirty="0"/>
-              <a:t>project demonstrates the practical application of C programming concepts in developing a complete software application.</a:t>
+              <a:t>The project demonstrates the practical application of C programming concepts in developing a complete software application.</a:t>
             </a:r>
           </a:p>
         </p:txBody>
@@ -4981,7 +5040,7 @@
           <p:cNvPr id="2" name="Title 1">
             <a:extLst>
               <a:ext uri="{FF2B5EF4-FFF2-40B4-BE49-F238E27FC236}">
-                <a16:creationId xmlns:a16="http://schemas.microsoft.com/office/drawing/2014/main" xmlns="" id="{806A50B1-CA47-93F4-AE81-CB7D81DB0CCD}"/>
+                <a16:creationId xmlns:a16="http://schemas.microsoft.com/office/drawing/2014/main" id="{806A50B1-CA47-93F4-AE81-CB7D81DB0CCD}"/>
               </a:ext>
             </a:extLst>
           </p:cNvPr>
@@ -5019,7 +5078,7 @@
           <p:cNvPr id="3" name="Subtitle 2">
             <a:extLst>
               <a:ext uri="{FF2B5EF4-FFF2-40B4-BE49-F238E27FC236}">
-                <a16:creationId xmlns:a16="http://schemas.microsoft.com/office/drawing/2014/main" xmlns="" id="{41887487-9DD7-4309-C4DF-1D74C7C3C822}"/>
+                <a16:creationId xmlns:a16="http://schemas.microsoft.com/office/drawing/2014/main" id="{41887487-9DD7-4309-C4DF-1D74C7C3C822}"/>
               </a:ext>
             </a:extLst>
           </p:cNvPr>
@@ -5161,7 +5220,7 @@
           <p:cNvPr id="2" name="Title 1">
             <a:extLst>
               <a:ext uri="{FF2B5EF4-FFF2-40B4-BE49-F238E27FC236}">
-                <a16:creationId xmlns:a16="http://schemas.microsoft.com/office/drawing/2014/main" xmlns="" id="{790F860A-5BC2-2A92-C549-C1481375F9A8}"/>
+                <a16:creationId xmlns:a16="http://schemas.microsoft.com/office/drawing/2014/main" id="{790F860A-5BC2-2A92-C549-C1481375F9A8}"/>
               </a:ext>
             </a:extLst>
           </p:cNvPr>
@@ -5197,7 +5256,7 @@
           <p:cNvPr id="3" name="Subtitle 2">
             <a:extLst>
               <a:ext uri="{FF2B5EF4-FFF2-40B4-BE49-F238E27FC236}">
-                <a16:creationId xmlns:a16="http://schemas.microsoft.com/office/drawing/2014/main" xmlns="" id="{15EAC4F1-F4EA-5CA9-069E-600B6D95299E}"/>
+                <a16:creationId xmlns:a16="http://schemas.microsoft.com/office/drawing/2014/main" id="{15EAC4F1-F4EA-5CA9-069E-600B6D95299E}"/>
               </a:ext>
             </a:extLst>
           </p:cNvPr>
@@ -5242,13 +5301,6 @@
               </a:rPr>
               <a:t>1. Lack of User Management</a:t>
             </a:r>
-            <a:r>
-              <a:rPr lang="en-GB" sz="2000" dirty="0">
-                <a:latin typeface="Times New Roman" panose="02020603050405020304" pitchFamily="18" charset="0"/>
-                <a:cs typeface="Times New Roman" panose="02020603050405020304" pitchFamily="18" charset="0"/>
-              </a:rPr>
-              <a:t/>
-            </a:r>
             <a:br>
               <a:rPr lang="en-GB" sz="2000" dirty="0">
                 <a:latin typeface="Times New Roman" panose="02020603050405020304" pitchFamily="18" charset="0"/>
@@ -5304,13 +5356,6 @@
               </a:rPr>
               <a:t>Absence of Match History and Leaderboard</a:t>
             </a:r>
-            <a:r>
-              <a:rPr lang="en-GB" sz="2000" dirty="0">
-                <a:latin typeface="Times New Roman" panose="02020603050405020304" pitchFamily="18" charset="0"/>
-                <a:cs typeface="Times New Roman" panose="02020603050405020304" pitchFamily="18" charset="0"/>
-              </a:rPr>
-              <a:t/>
-            </a:r>
             <a:br>
               <a:rPr lang="en-GB" sz="2000" dirty="0">
                 <a:latin typeface="Times New Roman" panose="02020603050405020304" pitchFamily="18" charset="0"/>
@@ -5351,13 +5396,6 @@
                 <a:cs typeface="Times New Roman" panose="02020603050405020304" pitchFamily="18" charset="0"/>
               </a:rPr>
               <a:t>Limited   Gameplay Features</a:t>
-            </a:r>
-            <a:r>
-              <a:rPr lang="en-GB" sz="2000" dirty="0">
-                <a:latin typeface="Times New Roman" panose="02020603050405020304" pitchFamily="18" charset="0"/>
-                <a:cs typeface="Times New Roman" panose="02020603050405020304" pitchFamily="18" charset="0"/>
-              </a:rPr>
-              <a:t/>
             </a:r>
             <a:br>
               <a:rPr lang="en-GB" sz="2000" dirty="0">
@@ -5470,40 +5508,2031 @@
             <p:ph type="title"/>
           </p:nvPr>
         </p:nvSpPr>
-        <p:spPr/>
+        <p:spPr>
+          <a:xfrm>
+            <a:off x="772885" y="0"/>
+            <a:ext cx="9775371" cy="1017361"/>
+          </a:xfrm>
+        </p:spPr>
         <p:txBody>
           <a:bodyPr>
             <a:normAutofit/>
           </a:bodyPr>
           <a:lstStyle/>
           <a:p>
-            <a:r>
-              <a:rPr lang="en-US" sz="6000" b="1" dirty="0" smtClean="0"/>
+            <a:pPr algn="ctr"/>
+            <a:r>
+              <a:rPr lang="en-US" dirty="0">
+                <a:latin typeface="Times New Roman" panose="02020603050405020304" pitchFamily="18" charset="0"/>
+                <a:cs typeface="Times New Roman" panose="02020603050405020304" pitchFamily="18" charset="0"/>
+              </a:rPr>
               <a:t>TEAM MEMBERS CONTRIBUTION</a:t>
             </a:r>
-            <a:endParaRPr lang="en-US" sz="6000" b="1" dirty="0"/>
           </a:p>
         </p:txBody>
       </p:sp>
-      <p:sp>
-        <p:nvSpPr>
-          <p:cNvPr id="3" name="Content Placeholder 2"/>
-          <p:cNvSpPr>
-            <a:spLocks noGrp="1"/>
-          </p:cNvSpPr>
+      <p:graphicFrame>
+        <p:nvGraphicFramePr>
+          <p:cNvPr id="4" name="Content Placeholder 3">
+            <a:extLst>
+              <a:ext uri="{FF2B5EF4-FFF2-40B4-BE49-F238E27FC236}">
+                <a16:creationId xmlns:a16="http://schemas.microsoft.com/office/drawing/2014/main" id="{37F001BB-DD57-E67E-29BC-2C7D75A17952}"/>
+              </a:ext>
+            </a:extLst>
+          </p:cNvPr>
+          <p:cNvGraphicFramePr>
+            <a:graphicFrameLocks noGrp="1"/>
+          </p:cNvGraphicFramePr>
           <p:nvPr>
             <p:ph idx="1"/>
+            <p:extLst>
+              <p:ext uri="{D42A27DB-BD31-4B8C-83A1-F6EECF244321}">
+                <p14:modId xmlns:p14="http://schemas.microsoft.com/office/powerpoint/2010/main" val="3405023732"/>
+              </p:ext>
+            </p:extLst>
           </p:nvPr>
-        </p:nvSpPr>
-        <p:spPr/>
-        <p:txBody>
-          <a:bodyPr/>
-          <a:lstStyle/>
-          <a:p>
-            <a:endParaRPr lang="en-US"/>
-          </a:p>
-        </p:txBody>
-      </p:sp>
+        </p:nvGraphicFramePr>
+        <p:xfrm>
+          <a:off x="979714" y="756104"/>
+          <a:ext cx="10003972" cy="5409146"/>
+        </p:xfrm>
+        <a:graphic>
+          <a:graphicData uri="http://schemas.openxmlformats.org/drawingml/2006/table">
+            <a:tbl>
+              <a:tblPr/>
+              <a:tblGrid>
+                <a:gridCol w="2500993">
+                  <a:extLst>
+                    <a:ext uri="{9D8B030D-6E8A-4147-A177-3AD203B41FA5}">
+                      <a16:colId xmlns:a16="http://schemas.microsoft.com/office/drawing/2014/main" val="2552326468"/>
+                    </a:ext>
+                  </a:extLst>
+                </a:gridCol>
+                <a:gridCol w="2500993">
+                  <a:extLst>
+                    <a:ext uri="{9D8B030D-6E8A-4147-A177-3AD203B41FA5}">
+                      <a16:colId xmlns:a16="http://schemas.microsoft.com/office/drawing/2014/main" val="150162057"/>
+                    </a:ext>
+                  </a:extLst>
+                </a:gridCol>
+                <a:gridCol w="2500993">
+                  <a:extLst>
+                    <a:ext uri="{9D8B030D-6E8A-4147-A177-3AD203B41FA5}">
+                      <a16:colId xmlns:a16="http://schemas.microsoft.com/office/drawing/2014/main" val="2636996169"/>
+                    </a:ext>
+                  </a:extLst>
+                </a:gridCol>
+                <a:gridCol w="2500993">
+                  <a:extLst>
+                    <a:ext uri="{9D8B030D-6E8A-4147-A177-3AD203B41FA5}">
+                      <a16:colId xmlns:a16="http://schemas.microsoft.com/office/drawing/2014/main" val="1849122840"/>
+                    </a:ext>
+                  </a:extLst>
+                </a:gridCol>
+              </a:tblGrid>
+              <a:tr h="239509">
+                <a:tc>
+                  <a:txBody>
+                    <a:bodyPr/>
+                    <a:lstStyle/>
+                    <a:p>
+                      <a:pPr algn="ctr">
+                        <a:buNone/>
+                      </a:pPr>
+                      <a:r>
+                        <a:rPr lang="en-US" sz="900" b="1"/>
+                        <a:t>S.N.</a:t>
+                      </a:r>
+                      <a:endParaRPr lang="en-US" sz="900"/>
+                    </a:p>
+                  </a:txBody>
+                  <a:tcPr marL="44859" marR="44859" marT="22430" marB="22430" anchor="ctr">
+                    <a:lnL>
+                      <a:noFill/>
+                    </a:lnL>
+                    <a:lnR>
+                      <a:noFill/>
+                    </a:lnR>
+                    <a:lnT>
+                      <a:noFill/>
+                    </a:lnT>
+                    <a:lnB>
+                      <a:noFill/>
+                    </a:lnB>
+                    <a:noFill/>
+                  </a:tcPr>
+                </a:tc>
+                <a:tc>
+                  <a:txBody>
+                    <a:bodyPr/>
+                    <a:lstStyle/>
+                    <a:p>
+                      <a:pPr>
+                        <a:buNone/>
+                      </a:pPr>
+                      <a:r>
+                        <a:rPr lang="en-US" sz="900" b="1"/>
+                        <a:t>Task / Activity</a:t>
+                      </a:r>
+                      <a:endParaRPr lang="en-US" sz="900"/>
+                    </a:p>
+                  </a:txBody>
+                  <a:tcPr marL="44859" marR="44859" marT="22430" marB="22430" anchor="ctr">
+                    <a:lnL>
+                      <a:noFill/>
+                    </a:lnL>
+                    <a:lnR>
+                      <a:noFill/>
+                    </a:lnR>
+                    <a:lnT>
+                      <a:noFill/>
+                    </a:lnT>
+                    <a:lnB>
+                      <a:noFill/>
+                    </a:lnB>
+                    <a:noFill/>
+                  </a:tcPr>
+                </a:tc>
+                <a:tc>
+                  <a:txBody>
+                    <a:bodyPr/>
+                    <a:lstStyle/>
+                    <a:p>
+                      <a:pPr algn="ctr">
+                        <a:buNone/>
+                      </a:pPr>
+                      <a:r>
+                        <a:rPr lang="en-US" sz="900" b="1"/>
+                        <a:t>Divya Sharma</a:t>
+                      </a:r>
+                      <a:endParaRPr lang="en-US" sz="900"/>
+                    </a:p>
+                  </a:txBody>
+                  <a:tcPr marL="44859" marR="44859" marT="22430" marB="22430" anchor="ctr">
+                    <a:lnL>
+                      <a:noFill/>
+                    </a:lnL>
+                    <a:lnR>
+                      <a:noFill/>
+                    </a:lnR>
+                    <a:lnT>
+                      <a:noFill/>
+                    </a:lnT>
+                    <a:lnB>
+                      <a:noFill/>
+                    </a:lnB>
+                    <a:noFill/>
+                  </a:tcPr>
+                </a:tc>
+                <a:tc>
+                  <a:txBody>
+                    <a:bodyPr/>
+                    <a:lstStyle/>
+                    <a:p>
+                      <a:pPr algn="ctr">
+                        <a:buNone/>
+                      </a:pPr>
+                      <a:r>
+                        <a:rPr lang="en-US" sz="900" b="1"/>
+                        <a:t>Sabina</a:t>
+                      </a:r>
+                      <a:endParaRPr lang="en-US" sz="900"/>
+                    </a:p>
+                  </a:txBody>
+                  <a:tcPr marL="44859" marR="44859" marT="22430" marB="22430" anchor="ctr">
+                    <a:lnL>
+                      <a:noFill/>
+                    </a:lnL>
+                    <a:lnR>
+                      <a:noFill/>
+                    </a:lnR>
+                    <a:lnT>
+                      <a:noFill/>
+                    </a:lnT>
+                    <a:lnB>
+                      <a:noFill/>
+                    </a:lnB>
+                    <a:noFill/>
+                  </a:tcPr>
+                </a:tc>
+                <a:extLst>
+                  <a:ext uri="{0D108BD9-81ED-4DB2-BD59-A6C34878D82A}">
+                    <a16:rowId xmlns:a16="http://schemas.microsoft.com/office/drawing/2014/main" val="4111058095"/>
+                  </a:ext>
+                </a:extLst>
+              </a:tr>
+              <a:tr h="239509">
+                <a:tc>
+                  <a:txBody>
+                    <a:bodyPr/>
+                    <a:lstStyle/>
+                    <a:p>
+                      <a:pPr algn="ctr">
+                        <a:buNone/>
+                      </a:pPr>
+                      <a:r>
+                        <a:rPr lang="en-US" sz="900"/>
+                        <a:t>1</a:t>
+                      </a:r>
+                    </a:p>
+                  </a:txBody>
+                  <a:tcPr marL="44859" marR="44859" marT="22430" marB="22430" anchor="ctr">
+                    <a:lnL>
+                      <a:noFill/>
+                    </a:lnL>
+                    <a:lnR>
+                      <a:noFill/>
+                    </a:lnR>
+                    <a:lnT>
+                      <a:noFill/>
+                    </a:lnT>
+                    <a:lnB>
+                      <a:noFill/>
+                    </a:lnB>
+                    <a:noFill/>
+                  </a:tcPr>
+                </a:tc>
+                <a:tc>
+                  <a:txBody>
+                    <a:bodyPr/>
+                    <a:lstStyle/>
+                    <a:p>
+                      <a:pPr marL="0" marR="0" lvl="0" indent="0" algn="l" defTabSz="914400" rtl="0" eaLnBrk="1" fontAlgn="auto" latinLnBrk="0" hangingPunct="1">
+                        <a:lnSpc>
+                          <a:spcPct val="100000"/>
+                        </a:lnSpc>
+                        <a:spcBef>
+                          <a:spcPts val="0"/>
+                        </a:spcBef>
+                        <a:spcAft>
+                          <a:spcPts val="0"/>
+                        </a:spcAft>
+                        <a:buClrTx/>
+                        <a:buSzTx/>
+                        <a:buFontTx/>
+                        <a:buNone/>
+                        <a:tabLst/>
+                        <a:defRPr/>
+                      </a:pPr>
+                      <a:r>
+                        <a:rPr lang="en-US" sz="900" dirty="0"/>
+                        <a:t>Requirement Analysis and Literature Review &amp; Background Study</a:t>
+                      </a:r>
+                    </a:p>
+                  </a:txBody>
+                  <a:tcPr marL="44859" marR="44859" marT="22430" marB="22430" anchor="ctr">
+                    <a:lnL>
+                      <a:noFill/>
+                    </a:lnL>
+                    <a:lnR>
+                      <a:noFill/>
+                    </a:lnR>
+                    <a:lnT>
+                      <a:noFill/>
+                    </a:lnT>
+                    <a:lnB>
+                      <a:noFill/>
+                    </a:lnB>
+                    <a:noFill/>
+                  </a:tcPr>
+                </a:tc>
+                <a:tc>
+                  <a:txBody>
+                    <a:bodyPr/>
+                    <a:lstStyle/>
+                    <a:p>
+                      <a:pPr marL="0" marR="0" lvl="0" indent="0" algn="ctr" defTabSz="914400" rtl="0" eaLnBrk="1" fontAlgn="auto" latinLnBrk="0" hangingPunct="1">
+                        <a:lnSpc>
+                          <a:spcPct val="100000"/>
+                        </a:lnSpc>
+                        <a:spcBef>
+                          <a:spcPts val="0"/>
+                        </a:spcBef>
+                        <a:spcAft>
+                          <a:spcPts val="0"/>
+                        </a:spcAft>
+                        <a:buClrTx/>
+                        <a:buSzTx/>
+                        <a:buFontTx/>
+                        <a:buNone/>
+                        <a:tabLst/>
+                        <a:defRPr/>
+                      </a:pPr>
+                      <a:r>
+                        <a:rPr lang="en-US" sz="900" dirty="0"/>
+                        <a:t>✔</a:t>
+                      </a:r>
+                    </a:p>
+                    <a:p>
+                      <a:pPr algn="ctr">
+                        <a:buNone/>
+                      </a:pPr>
+                      <a:endParaRPr lang="en-US" sz="900" dirty="0"/>
+                    </a:p>
+                  </a:txBody>
+                  <a:tcPr marL="44859" marR="44859" marT="22430" marB="22430" anchor="ctr">
+                    <a:lnL>
+                      <a:noFill/>
+                    </a:lnL>
+                    <a:lnR>
+                      <a:noFill/>
+                    </a:lnR>
+                    <a:lnT>
+                      <a:noFill/>
+                    </a:lnT>
+                    <a:lnB>
+                      <a:noFill/>
+                    </a:lnB>
+                    <a:noFill/>
+                  </a:tcPr>
+                </a:tc>
+                <a:tc>
+                  <a:txBody>
+                    <a:bodyPr/>
+                    <a:lstStyle/>
+                    <a:p>
+                      <a:pPr algn="ctr">
+                        <a:buNone/>
+                      </a:pPr>
+                      <a:r>
+                        <a:rPr lang="en-US" sz="900"/>
+                        <a:t>✔</a:t>
+                      </a:r>
+                    </a:p>
+                  </a:txBody>
+                  <a:tcPr marL="44859" marR="44859" marT="22430" marB="22430" anchor="ctr">
+                    <a:lnL>
+                      <a:noFill/>
+                    </a:lnL>
+                    <a:lnR>
+                      <a:noFill/>
+                    </a:lnR>
+                    <a:lnT>
+                      <a:noFill/>
+                    </a:lnT>
+                    <a:lnB>
+                      <a:noFill/>
+                    </a:lnB>
+                    <a:noFill/>
+                  </a:tcPr>
+                </a:tc>
+                <a:extLst>
+                  <a:ext uri="{0D108BD9-81ED-4DB2-BD59-A6C34878D82A}">
+                    <a16:rowId xmlns:a16="http://schemas.microsoft.com/office/drawing/2014/main" val="2032505115"/>
+                  </a:ext>
+                </a:extLst>
+              </a:tr>
+              <a:tr h="413193">
+                <a:tc>
+                  <a:txBody>
+                    <a:bodyPr/>
+                    <a:lstStyle/>
+                    <a:p>
+                      <a:pPr algn="ctr">
+                        <a:buNone/>
+                      </a:pPr>
+                      <a:r>
+                        <a:rPr lang="en-US" sz="900" dirty="0"/>
+                        <a:t>2</a:t>
+                      </a:r>
+                    </a:p>
+                  </a:txBody>
+                  <a:tcPr marL="44859" marR="44859" marT="22430" marB="22430" anchor="ctr">
+                    <a:lnL>
+                      <a:noFill/>
+                    </a:lnL>
+                    <a:lnR>
+                      <a:noFill/>
+                    </a:lnR>
+                    <a:lnT>
+                      <a:noFill/>
+                    </a:lnT>
+                    <a:lnB>
+                      <a:noFill/>
+                    </a:lnB>
+                    <a:noFill/>
+                  </a:tcPr>
+                </a:tc>
+                <a:tc>
+                  <a:txBody>
+                    <a:bodyPr/>
+                    <a:lstStyle/>
+                    <a:p>
+                      <a:pPr>
+                        <a:buNone/>
+                      </a:pPr>
+                      <a:r>
+                        <a:rPr lang="en-US" sz="900"/>
+                        <a:t>Problem Statement &amp; Objectives</a:t>
+                      </a:r>
+                    </a:p>
+                  </a:txBody>
+                  <a:tcPr marL="44859" marR="44859" marT="22430" marB="22430" anchor="ctr">
+                    <a:lnL>
+                      <a:noFill/>
+                    </a:lnL>
+                    <a:lnR>
+                      <a:noFill/>
+                    </a:lnR>
+                    <a:lnT>
+                      <a:noFill/>
+                    </a:lnT>
+                    <a:lnB>
+                      <a:noFill/>
+                    </a:lnB>
+                    <a:noFill/>
+                  </a:tcPr>
+                </a:tc>
+                <a:tc>
+                  <a:txBody>
+                    <a:bodyPr/>
+                    <a:lstStyle/>
+                    <a:p>
+                      <a:pPr algn="ctr">
+                        <a:buNone/>
+                      </a:pPr>
+                      <a:r>
+                        <a:rPr lang="en-US" sz="900"/>
+                        <a:t>✔</a:t>
+                      </a:r>
+                    </a:p>
+                  </a:txBody>
+                  <a:tcPr marL="44859" marR="44859" marT="22430" marB="22430" anchor="ctr">
+                    <a:lnL>
+                      <a:noFill/>
+                    </a:lnL>
+                    <a:lnR>
+                      <a:noFill/>
+                    </a:lnR>
+                    <a:lnT>
+                      <a:noFill/>
+                    </a:lnT>
+                    <a:lnB>
+                      <a:noFill/>
+                    </a:lnB>
+                    <a:noFill/>
+                  </a:tcPr>
+                </a:tc>
+                <a:tc>
+                  <a:txBody>
+                    <a:bodyPr/>
+                    <a:lstStyle/>
+                    <a:p>
+                      <a:pPr algn="ctr">
+                        <a:buNone/>
+                      </a:pPr>
+                      <a:r>
+                        <a:rPr lang="en-US" sz="900" dirty="0"/>
+                        <a:t>✔</a:t>
+                      </a:r>
+                    </a:p>
+                  </a:txBody>
+                  <a:tcPr marL="44859" marR="44859" marT="22430" marB="22430" anchor="ctr">
+                    <a:lnL>
+                      <a:noFill/>
+                    </a:lnL>
+                    <a:lnR>
+                      <a:noFill/>
+                    </a:lnR>
+                    <a:lnT>
+                      <a:noFill/>
+                    </a:lnT>
+                    <a:lnB>
+                      <a:noFill/>
+                    </a:lnB>
+                    <a:noFill/>
+                  </a:tcPr>
+                </a:tc>
+                <a:extLst>
+                  <a:ext uri="{0D108BD9-81ED-4DB2-BD59-A6C34878D82A}">
+                    <a16:rowId xmlns:a16="http://schemas.microsoft.com/office/drawing/2014/main" val="1183224937"/>
+                  </a:ext>
+                </a:extLst>
+              </a:tr>
+              <a:tr h="413193">
+                <a:tc>
+                  <a:txBody>
+                    <a:bodyPr/>
+                    <a:lstStyle/>
+                    <a:p>
+                      <a:pPr algn="ctr">
+                        <a:buNone/>
+                      </a:pPr>
+                      <a:r>
+                        <a:rPr lang="en-US" sz="900" dirty="0"/>
+                        <a:t>3</a:t>
+                      </a:r>
+                    </a:p>
+                  </a:txBody>
+                  <a:tcPr marL="44859" marR="44859" marT="22430" marB="22430" anchor="ctr">
+                    <a:lnL>
+                      <a:noFill/>
+                    </a:lnL>
+                    <a:lnR>
+                      <a:noFill/>
+                    </a:lnR>
+                    <a:lnT>
+                      <a:noFill/>
+                    </a:lnT>
+                    <a:lnB>
+                      <a:noFill/>
+                    </a:lnB>
+                    <a:noFill/>
+                  </a:tcPr>
+                </a:tc>
+                <a:tc>
+                  <a:txBody>
+                    <a:bodyPr/>
+                    <a:lstStyle/>
+                    <a:p>
+                      <a:pPr>
+                        <a:buNone/>
+                      </a:pPr>
+                      <a:r>
+                        <a:rPr lang="en-US" sz="900" dirty="0"/>
+                        <a:t>System Design (DFD &amp; Flowchart)</a:t>
+                      </a:r>
+                    </a:p>
+                  </a:txBody>
+                  <a:tcPr marL="44859" marR="44859" marT="22430" marB="22430" anchor="ctr">
+                    <a:lnL>
+                      <a:noFill/>
+                    </a:lnL>
+                    <a:lnR>
+                      <a:noFill/>
+                    </a:lnR>
+                    <a:lnT>
+                      <a:noFill/>
+                    </a:lnT>
+                    <a:lnB>
+                      <a:noFill/>
+                    </a:lnB>
+                    <a:noFill/>
+                  </a:tcPr>
+                </a:tc>
+                <a:tc>
+                  <a:txBody>
+                    <a:bodyPr/>
+                    <a:lstStyle/>
+                    <a:p>
+                      <a:pPr algn="ctr">
+                        <a:buNone/>
+                      </a:pPr>
+                      <a:r>
+                        <a:rPr lang="en-US" sz="900"/>
+                        <a:t>✔</a:t>
+                      </a:r>
+                    </a:p>
+                  </a:txBody>
+                  <a:tcPr marL="44859" marR="44859" marT="22430" marB="22430" anchor="ctr">
+                    <a:lnL>
+                      <a:noFill/>
+                    </a:lnL>
+                    <a:lnR>
+                      <a:noFill/>
+                    </a:lnR>
+                    <a:lnT>
+                      <a:noFill/>
+                    </a:lnT>
+                    <a:lnB>
+                      <a:noFill/>
+                    </a:lnB>
+                    <a:noFill/>
+                  </a:tcPr>
+                </a:tc>
+                <a:tc>
+                  <a:txBody>
+                    <a:bodyPr/>
+                    <a:lstStyle/>
+                    <a:p>
+                      <a:pPr algn="ctr">
+                        <a:buNone/>
+                      </a:pPr>
+                      <a:r>
+                        <a:rPr lang="en-US" sz="900"/>
+                        <a:t>✔</a:t>
+                      </a:r>
+                    </a:p>
+                  </a:txBody>
+                  <a:tcPr marL="44859" marR="44859" marT="22430" marB="22430" anchor="ctr">
+                    <a:lnL>
+                      <a:noFill/>
+                    </a:lnL>
+                    <a:lnR>
+                      <a:noFill/>
+                    </a:lnR>
+                    <a:lnT>
+                      <a:noFill/>
+                    </a:lnT>
+                    <a:lnB>
+                      <a:noFill/>
+                    </a:lnB>
+                    <a:noFill/>
+                  </a:tcPr>
+                </a:tc>
+                <a:extLst>
+                  <a:ext uri="{0D108BD9-81ED-4DB2-BD59-A6C34878D82A}">
+                    <a16:rowId xmlns:a16="http://schemas.microsoft.com/office/drawing/2014/main" val="1746497574"/>
+                  </a:ext>
+                </a:extLst>
+              </a:tr>
+              <a:tr h="239509">
+                <a:tc>
+                  <a:txBody>
+                    <a:bodyPr/>
+                    <a:lstStyle/>
+                    <a:p>
+                      <a:pPr algn="ctr">
+                        <a:buNone/>
+                      </a:pPr>
+                      <a:r>
+                        <a:rPr lang="en-US" sz="900" dirty="0"/>
+                        <a:t>4</a:t>
+                      </a:r>
+                    </a:p>
+                  </a:txBody>
+                  <a:tcPr marL="44859" marR="44859" marT="22430" marB="22430" anchor="ctr">
+                    <a:lnL>
+                      <a:noFill/>
+                    </a:lnL>
+                    <a:lnR>
+                      <a:noFill/>
+                    </a:lnR>
+                    <a:lnT>
+                      <a:noFill/>
+                    </a:lnT>
+                    <a:lnB>
+                      <a:noFill/>
+                    </a:lnB>
+                    <a:noFill/>
+                  </a:tcPr>
+                </a:tc>
+                <a:tc>
+                  <a:txBody>
+                    <a:bodyPr/>
+                    <a:lstStyle/>
+                    <a:p>
+                      <a:pPr>
+                        <a:buNone/>
+                      </a:pPr>
+                      <a:r>
+                        <a:rPr lang="en-US" sz="900"/>
+                        <a:t>User Registration Module</a:t>
+                      </a:r>
+                    </a:p>
+                  </a:txBody>
+                  <a:tcPr marL="44859" marR="44859" marT="22430" marB="22430" anchor="ctr">
+                    <a:lnL>
+                      <a:noFill/>
+                    </a:lnL>
+                    <a:lnR>
+                      <a:noFill/>
+                    </a:lnR>
+                    <a:lnT>
+                      <a:noFill/>
+                    </a:lnT>
+                    <a:lnB>
+                      <a:noFill/>
+                    </a:lnB>
+                    <a:noFill/>
+                  </a:tcPr>
+                </a:tc>
+                <a:tc>
+                  <a:txBody>
+                    <a:bodyPr/>
+                    <a:lstStyle/>
+                    <a:p>
+                      <a:pPr algn="ctr">
+                        <a:buNone/>
+                      </a:pPr>
+                      <a:r>
+                        <a:rPr lang="en-US" sz="900"/>
+                        <a:t>✔</a:t>
+                      </a:r>
+                    </a:p>
+                  </a:txBody>
+                  <a:tcPr marL="44859" marR="44859" marT="22430" marB="22430" anchor="ctr">
+                    <a:lnL>
+                      <a:noFill/>
+                    </a:lnL>
+                    <a:lnR>
+                      <a:noFill/>
+                    </a:lnR>
+                    <a:lnT>
+                      <a:noFill/>
+                    </a:lnT>
+                    <a:lnB>
+                      <a:noFill/>
+                    </a:lnB>
+                    <a:noFill/>
+                  </a:tcPr>
+                </a:tc>
+                <a:tc>
+                  <a:txBody>
+                    <a:bodyPr/>
+                    <a:lstStyle/>
+                    <a:p>
+                      <a:pPr algn="ctr">
+                        <a:buNone/>
+                      </a:pPr>
+                      <a:endParaRPr lang="en-US" sz="900" dirty="0"/>
+                    </a:p>
+                  </a:txBody>
+                  <a:tcPr marL="44859" marR="44859" marT="22430" marB="22430" anchor="ctr">
+                    <a:lnL>
+                      <a:noFill/>
+                    </a:lnL>
+                    <a:lnR>
+                      <a:noFill/>
+                    </a:lnR>
+                    <a:lnT>
+                      <a:noFill/>
+                    </a:lnT>
+                    <a:lnB>
+                      <a:noFill/>
+                    </a:lnB>
+                    <a:noFill/>
+                  </a:tcPr>
+                </a:tc>
+                <a:extLst>
+                  <a:ext uri="{0D108BD9-81ED-4DB2-BD59-A6C34878D82A}">
+                    <a16:rowId xmlns:a16="http://schemas.microsoft.com/office/drawing/2014/main" val="4161440268"/>
+                  </a:ext>
+                </a:extLst>
+              </a:tr>
+              <a:tr h="413193">
+                <a:tc>
+                  <a:txBody>
+                    <a:bodyPr/>
+                    <a:lstStyle/>
+                    <a:p>
+                      <a:pPr algn="ctr">
+                        <a:buNone/>
+                      </a:pPr>
+                      <a:r>
+                        <a:rPr lang="en-US" sz="900" dirty="0"/>
+                        <a:t>5</a:t>
+                      </a:r>
+                    </a:p>
+                  </a:txBody>
+                  <a:tcPr marL="44859" marR="44859" marT="22430" marB="22430" anchor="ctr">
+                    <a:lnL>
+                      <a:noFill/>
+                    </a:lnL>
+                    <a:lnR>
+                      <a:noFill/>
+                    </a:lnR>
+                    <a:lnT>
+                      <a:noFill/>
+                    </a:lnT>
+                    <a:lnB>
+                      <a:noFill/>
+                    </a:lnB>
+                    <a:noFill/>
+                  </a:tcPr>
+                </a:tc>
+                <a:tc>
+                  <a:txBody>
+                    <a:bodyPr/>
+                    <a:lstStyle/>
+                    <a:p>
+                      <a:pPr>
+                        <a:buNone/>
+                      </a:pPr>
+                      <a:r>
+                        <a:rPr lang="en-US" sz="900"/>
+                        <a:t>Login Authentication Module</a:t>
+                      </a:r>
+                    </a:p>
+                  </a:txBody>
+                  <a:tcPr marL="44859" marR="44859" marT="22430" marB="22430" anchor="ctr">
+                    <a:lnL>
+                      <a:noFill/>
+                    </a:lnL>
+                    <a:lnR>
+                      <a:noFill/>
+                    </a:lnR>
+                    <a:lnT>
+                      <a:noFill/>
+                    </a:lnT>
+                    <a:lnB>
+                      <a:noFill/>
+                    </a:lnB>
+                    <a:noFill/>
+                  </a:tcPr>
+                </a:tc>
+                <a:tc>
+                  <a:txBody>
+                    <a:bodyPr/>
+                    <a:lstStyle/>
+                    <a:p>
+                      <a:pPr algn="ctr">
+                        <a:buNone/>
+                      </a:pPr>
+                      <a:r>
+                        <a:rPr lang="en-US" sz="900"/>
+                        <a:t>✔</a:t>
+                      </a:r>
+                    </a:p>
+                  </a:txBody>
+                  <a:tcPr marL="44859" marR="44859" marT="22430" marB="22430" anchor="ctr">
+                    <a:lnL>
+                      <a:noFill/>
+                    </a:lnL>
+                    <a:lnR>
+                      <a:noFill/>
+                    </a:lnR>
+                    <a:lnT>
+                      <a:noFill/>
+                    </a:lnT>
+                    <a:lnB>
+                      <a:noFill/>
+                    </a:lnB>
+                    <a:noFill/>
+                  </a:tcPr>
+                </a:tc>
+                <a:tc>
+                  <a:txBody>
+                    <a:bodyPr/>
+                    <a:lstStyle/>
+                    <a:p>
+                      <a:pPr algn="ctr">
+                        <a:buNone/>
+                      </a:pPr>
+                      <a:endParaRPr lang="en-US" sz="900"/>
+                    </a:p>
+                  </a:txBody>
+                  <a:tcPr marL="44859" marR="44859" marT="22430" marB="22430" anchor="ctr">
+                    <a:lnL>
+                      <a:noFill/>
+                    </a:lnL>
+                    <a:lnR>
+                      <a:noFill/>
+                    </a:lnR>
+                    <a:lnT>
+                      <a:noFill/>
+                    </a:lnT>
+                    <a:lnB>
+                      <a:noFill/>
+                    </a:lnB>
+                    <a:noFill/>
+                  </a:tcPr>
+                </a:tc>
+                <a:extLst>
+                  <a:ext uri="{0D108BD9-81ED-4DB2-BD59-A6C34878D82A}">
+                    <a16:rowId xmlns:a16="http://schemas.microsoft.com/office/drawing/2014/main" val="1572317297"/>
+                  </a:ext>
+                </a:extLst>
+              </a:tr>
+              <a:tr h="413193">
+                <a:tc>
+                  <a:txBody>
+                    <a:bodyPr/>
+                    <a:lstStyle/>
+                    <a:p>
+                      <a:pPr algn="ctr">
+                        <a:buNone/>
+                      </a:pPr>
+                      <a:r>
+                        <a:rPr lang="en-US" sz="900" dirty="0"/>
+                        <a:t>6</a:t>
+                      </a:r>
+                    </a:p>
+                  </a:txBody>
+                  <a:tcPr marL="44859" marR="44859" marT="22430" marB="22430" anchor="ctr">
+                    <a:lnL>
+                      <a:noFill/>
+                    </a:lnL>
+                    <a:lnR>
+                      <a:noFill/>
+                    </a:lnR>
+                    <a:lnT>
+                      <a:noFill/>
+                    </a:lnT>
+                    <a:lnB>
+                      <a:noFill/>
+                    </a:lnB>
+                    <a:noFill/>
+                  </a:tcPr>
+                </a:tc>
+                <a:tc>
+                  <a:txBody>
+                    <a:bodyPr/>
+                    <a:lstStyle/>
+                    <a:p>
+                      <a:pPr>
+                        <a:buNone/>
+                      </a:pPr>
+                      <a:r>
+                        <a:rPr lang="en-US" sz="900"/>
+                        <a:t>Single Player Game Module</a:t>
+                      </a:r>
+                    </a:p>
+                  </a:txBody>
+                  <a:tcPr marL="44859" marR="44859" marT="22430" marB="22430" anchor="ctr">
+                    <a:lnL>
+                      <a:noFill/>
+                    </a:lnL>
+                    <a:lnR>
+                      <a:noFill/>
+                    </a:lnR>
+                    <a:lnT>
+                      <a:noFill/>
+                    </a:lnT>
+                    <a:lnB>
+                      <a:noFill/>
+                    </a:lnB>
+                    <a:noFill/>
+                  </a:tcPr>
+                </a:tc>
+                <a:tc>
+                  <a:txBody>
+                    <a:bodyPr/>
+                    <a:lstStyle/>
+                    <a:p>
+                      <a:pPr algn="ctr">
+                        <a:buNone/>
+                      </a:pPr>
+                      <a:r>
+                        <a:rPr lang="en-US" sz="900" dirty="0"/>
+                        <a:t>✔</a:t>
+                      </a:r>
+                    </a:p>
+                  </a:txBody>
+                  <a:tcPr marL="44859" marR="44859" marT="22430" marB="22430" anchor="ctr">
+                    <a:lnL>
+                      <a:noFill/>
+                    </a:lnL>
+                    <a:lnR>
+                      <a:noFill/>
+                    </a:lnR>
+                    <a:lnT>
+                      <a:noFill/>
+                    </a:lnT>
+                    <a:lnB>
+                      <a:noFill/>
+                    </a:lnB>
+                    <a:noFill/>
+                  </a:tcPr>
+                </a:tc>
+                <a:tc>
+                  <a:txBody>
+                    <a:bodyPr/>
+                    <a:lstStyle/>
+                    <a:p>
+                      <a:pPr algn="ctr">
+                        <a:buNone/>
+                      </a:pPr>
+                      <a:endParaRPr lang="en-US" sz="900"/>
+                    </a:p>
+                  </a:txBody>
+                  <a:tcPr marL="44859" marR="44859" marT="22430" marB="22430" anchor="ctr">
+                    <a:lnL>
+                      <a:noFill/>
+                    </a:lnL>
+                    <a:lnR>
+                      <a:noFill/>
+                    </a:lnR>
+                    <a:lnT>
+                      <a:noFill/>
+                    </a:lnT>
+                    <a:lnB>
+                      <a:noFill/>
+                    </a:lnB>
+                    <a:noFill/>
+                  </a:tcPr>
+                </a:tc>
+                <a:extLst>
+                  <a:ext uri="{0D108BD9-81ED-4DB2-BD59-A6C34878D82A}">
+                    <a16:rowId xmlns:a16="http://schemas.microsoft.com/office/drawing/2014/main" val="1996340715"/>
+                  </a:ext>
+                </a:extLst>
+              </a:tr>
+              <a:tr h="413193">
+                <a:tc>
+                  <a:txBody>
+                    <a:bodyPr/>
+                    <a:lstStyle/>
+                    <a:p>
+                      <a:pPr algn="ctr">
+                        <a:buNone/>
+                      </a:pPr>
+                      <a:r>
+                        <a:rPr lang="en-US" sz="900" dirty="0"/>
+                        <a:t>7</a:t>
+                      </a:r>
+                    </a:p>
+                  </a:txBody>
+                  <a:tcPr marL="44859" marR="44859" marT="22430" marB="22430" anchor="ctr">
+                    <a:lnL>
+                      <a:noFill/>
+                    </a:lnL>
+                    <a:lnR>
+                      <a:noFill/>
+                    </a:lnR>
+                    <a:lnT>
+                      <a:noFill/>
+                    </a:lnT>
+                    <a:lnB>
+                      <a:noFill/>
+                    </a:lnB>
+                    <a:noFill/>
+                  </a:tcPr>
+                </a:tc>
+                <a:tc>
+                  <a:txBody>
+                    <a:bodyPr/>
+                    <a:lstStyle/>
+                    <a:p>
+                      <a:pPr>
+                        <a:buNone/>
+                      </a:pPr>
+                      <a:r>
+                        <a:rPr lang="en-US" sz="900"/>
+                        <a:t>Multiplayer Game Module</a:t>
+                      </a:r>
+                    </a:p>
+                  </a:txBody>
+                  <a:tcPr marL="44859" marR="44859" marT="22430" marB="22430" anchor="ctr">
+                    <a:lnL>
+                      <a:noFill/>
+                    </a:lnL>
+                    <a:lnR>
+                      <a:noFill/>
+                    </a:lnR>
+                    <a:lnT>
+                      <a:noFill/>
+                    </a:lnT>
+                    <a:lnB>
+                      <a:noFill/>
+                    </a:lnB>
+                    <a:noFill/>
+                  </a:tcPr>
+                </a:tc>
+                <a:tc>
+                  <a:txBody>
+                    <a:bodyPr/>
+                    <a:lstStyle/>
+                    <a:p>
+                      <a:pPr marL="0" marR="0" lvl="0" indent="0" algn="ctr" defTabSz="914400" rtl="0" eaLnBrk="1" fontAlgn="auto" latinLnBrk="0" hangingPunct="1">
+                        <a:lnSpc>
+                          <a:spcPct val="100000"/>
+                        </a:lnSpc>
+                        <a:spcBef>
+                          <a:spcPts val="0"/>
+                        </a:spcBef>
+                        <a:spcAft>
+                          <a:spcPts val="0"/>
+                        </a:spcAft>
+                        <a:buClrTx/>
+                        <a:buSzTx/>
+                        <a:buFontTx/>
+                        <a:buNone/>
+                        <a:tabLst/>
+                        <a:defRPr/>
+                      </a:pPr>
+                      <a:r>
+                        <a:rPr lang="en-US" sz="900" dirty="0"/>
+                        <a:t>✔</a:t>
+                      </a:r>
+                    </a:p>
+                    <a:p>
+                      <a:pPr algn="ctr">
+                        <a:buNone/>
+                      </a:pPr>
+                      <a:endParaRPr lang="en-US" sz="900" dirty="0"/>
+                    </a:p>
+                  </a:txBody>
+                  <a:tcPr marL="44859" marR="44859" marT="22430" marB="22430" anchor="ctr">
+                    <a:lnL>
+                      <a:noFill/>
+                    </a:lnL>
+                    <a:lnR>
+                      <a:noFill/>
+                    </a:lnR>
+                    <a:lnT>
+                      <a:noFill/>
+                    </a:lnT>
+                    <a:lnB>
+                      <a:noFill/>
+                    </a:lnB>
+                    <a:noFill/>
+                  </a:tcPr>
+                </a:tc>
+                <a:tc>
+                  <a:txBody>
+                    <a:bodyPr/>
+                    <a:lstStyle/>
+                    <a:p>
+                      <a:pPr algn="ctr">
+                        <a:buNone/>
+                      </a:pPr>
+                      <a:endParaRPr lang="en-US" sz="900" dirty="0"/>
+                    </a:p>
+                  </a:txBody>
+                  <a:tcPr marL="44859" marR="44859" marT="22430" marB="22430" anchor="ctr">
+                    <a:lnL>
+                      <a:noFill/>
+                    </a:lnL>
+                    <a:lnR>
+                      <a:noFill/>
+                    </a:lnR>
+                    <a:lnT>
+                      <a:noFill/>
+                    </a:lnT>
+                    <a:lnB>
+                      <a:noFill/>
+                    </a:lnB>
+                    <a:noFill/>
+                  </a:tcPr>
+                </a:tc>
+                <a:extLst>
+                  <a:ext uri="{0D108BD9-81ED-4DB2-BD59-A6C34878D82A}">
+                    <a16:rowId xmlns:a16="http://schemas.microsoft.com/office/drawing/2014/main" val="1829323907"/>
+                  </a:ext>
+                </a:extLst>
+              </a:tr>
+              <a:tr h="239509">
+                <a:tc>
+                  <a:txBody>
+                    <a:bodyPr/>
+                    <a:lstStyle/>
+                    <a:p>
+                      <a:pPr algn="ctr">
+                        <a:buNone/>
+                      </a:pPr>
+                      <a:r>
+                        <a:rPr lang="en-US" sz="900" dirty="0"/>
+                        <a:t>8</a:t>
+                      </a:r>
+                    </a:p>
+                  </a:txBody>
+                  <a:tcPr marL="44859" marR="44859" marT="22430" marB="22430" anchor="ctr">
+                    <a:lnL>
+                      <a:noFill/>
+                    </a:lnL>
+                    <a:lnR>
+                      <a:noFill/>
+                    </a:lnR>
+                    <a:lnT>
+                      <a:noFill/>
+                    </a:lnT>
+                    <a:lnB>
+                      <a:noFill/>
+                    </a:lnB>
+                    <a:noFill/>
+                  </a:tcPr>
+                </a:tc>
+                <a:tc>
+                  <a:txBody>
+                    <a:bodyPr/>
+                    <a:lstStyle/>
+                    <a:p>
+                      <a:pPr>
+                        <a:buNone/>
+                      </a:pPr>
+                      <a:r>
+                        <a:rPr lang="en-US" sz="900"/>
+                        <a:t>Leaderboard Module</a:t>
+                      </a:r>
+                    </a:p>
+                  </a:txBody>
+                  <a:tcPr marL="44859" marR="44859" marT="22430" marB="22430" anchor="ctr">
+                    <a:lnL>
+                      <a:noFill/>
+                    </a:lnL>
+                    <a:lnR>
+                      <a:noFill/>
+                    </a:lnR>
+                    <a:lnT>
+                      <a:noFill/>
+                    </a:lnT>
+                    <a:lnB>
+                      <a:noFill/>
+                    </a:lnB>
+                    <a:noFill/>
+                  </a:tcPr>
+                </a:tc>
+                <a:tc>
+                  <a:txBody>
+                    <a:bodyPr/>
+                    <a:lstStyle/>
+                    <a:p>
+                      <a:pPr algn="ctr">
+                        <a:buNone/>
+                      </a:pPr>
+                      <a:endParaRPr lang="en-US" sz="900"/>
+                    </a:p>
+                  </a:txBody>
+                  <a:tcPr marL="44859" marR="44859" marT="22430" marB="22430" anchor="ctr">
+                    <a:lnL>
+                      <a:noFill/>
+                    </a:lnL>
+                    <a:lnR>
+                      <a:noFill/>
+                    </a:lnR>
+                    <a:lnT>
+                      <a:noFill/>
+                    </a:lnT>
+                    <a:lnB>
+                      <a:noFill/>
+                    </a:lnB>
+                    <a:noFill/>
+                  </a:tcPr>
+                </a:tc>
+                <a:tc>
+                  <a:txBody>
+                    <a:bodyPr/>
+                    <a:lstStyle/>
+                    <a:p>
+                      <a:pPr algn="ctr">
+                        <a:buNone/>
+                      </a:pPr>
+                      <a:r>
+                        <a:rPr lang="en-US" sz="900"/>
+                        <a:t>✔</a:t>
+                      </a:r>
+                    </a:p>
+                  </a:txBody>
+                  <a:tcPr marL="44859" marR="44859" marT="22430" marB="22430" anchor="ctr">
+                    <a:lnL>
+                      <a:noFill/>
+                    </a:lnL>
+                    <a:lnR>
+                      <a:noFill/>
+                    </a:lnR>
+                    <a:lnT>
+                      <a:noFill/>
+                    </a:lnT>
+                    <a:lnB>
+                      <a:noFill/>
+                    </a:lnB>
+                    <a:noFill/>
+                  </a:tcPr>
+                </a:tc>
+                <a:extLst>
+                  <a:ext uri="{0D108BD9-81ED-4DB2-BD59-A6C34878D82A}">
+                    <a16:rowId xmlns:a16="http://schemas.microsoft.com/office/drawing/2014/main" val="4086177249"/>
+                  </a:ext>
+                </a:extLst>
+              </a:tr>
+              <a:tr h="239509">
+                <a:tc>
+                  <a:txBody>
+                    <a:bodyPr/>
+                    <a:lstStyle/>
+                    <a:p>
+                      <a:pPr algn="ctr">
+                        <a:buNone/>
+                      </a:pPr>
+                      <a:r>
+                        <a:rPr lang="en-US" sz="900" dirty="0"/>
+                        <a:t>9</a:t>
+                      </a:r>
+                    </a:p>
+                  </a:txBody>
+                  <a:tcPr marL="44859" marR="44859" marT="22430" marB="22430" anchor="ctr">
+                    <a:lnL>
+                      <a:noFill/>
+                    </a:lnL>
+                    <a:lnR>
+                      <a:noFill/>
+                    </a:lnR>
+                    <a:lnT>
+                      <a:noFill/>
+                    </a:lnT>
+                    <a:lnB>
+                      <a:noFill/>
+                    </a:lnB>
+                    <a:noFill/>
+                  </a:tcPr>
+                </a:tc>
+                <a:tc>
+                  <a:txBody>
+                    <a:bodyPr/>
+                    <a:lstStyle/>
+                    <a:p>
+                      <a:pPr>
+                        <a:buNone/>
+                      </a:pPr>
+                      <a:r>
+                        <a:rPr lang="en-US" sz="900"/>
+                        <a:t>Match History Module</a:t>
+                      </a:r>
+                    </a:p>
+                  </a:txBody>
+                  <a:tcPr marL="44859" marR="44859" marT="22430" marB="22430" anchor="ctr">
+                    <a:lnL>
+                      <a:noFill/>
+                    </a:lnL>
+                    <a:lnR>
+                      <a:noFill/>
+                    </a:lnR>
+                    <a:lnT>
+                      <a:noFill/>
+                    </a:lnT>
+                    <a:lnB>
+                      <a:noFill/>
+                    </a:lnB>
+                    <a:noFill/>
+                  </a:tcPr>
+                </a:tc>
+                <a:tc>
+                  <a:txBody>
+                    <a:bodyPr/>
+                    <a:lstStyle/>
+                    <a:p>
+                      <a:pPr algn="ctr">
+                        <a:buNone/>
+                      </a:pPr>
+                      <a:endParaRPr lang="en-US" sz="900"/>
+                    </a:p>
+                  </a:txBody>
+                  <a:tcPr marL="44859" marR="44859" marT="22430" marB="22430" anchor="ctr">
+                    <a:lnL>
+                      <a:noFill/>
+                    </a:lnL>
+                    <a:lnR>
+                      <a:noFill/>
+                    </a:lnR>
+                    <a:lnT>
+                      <a:noFill/>
+                    </a:lnT>
+                    <a:lnB>
+                      <a:noFill/>
+                    </a:lnB>
+                    <a:noFill/>
+                  </a:tcPr>
+                </a:tc>
+                <a:tc>
+                  <a:txBody>
+                    <a:bodyPr/>
+                    <a:lstStyle/>
+                    <a:p>
+                      <a:pPr algn="ctr">
+                        <a:buNone/>
+                      </a:pPr>
+                      <a:r>
+                        <a:rPr lang="en-US" sz="900"/>
+                        <a:t>✔</a:t>
+                      </a:r>
+                    </a:p>
+                  </a:txBody>
+                  <a:tcPr marL="44859" marR="44859" marT="22430" marB="22430" anchor="ctr">
+                    <a:lnL>
+                      <a:noFill/>
+                    </a:lnL>
+                    <a:lnR>
+                      <a:noFill/>
+                    </a:lnR>
+                    <a:lnT>
+                      <a:noFill/>
+                    </a:lnT>
+                    <a:lnB>
+                      <a:noFill/>
+                    </a:lnB>
+                    <a:noFill/>
+                  </a:tcPr>
+                </a:tc>
+                <a:extLst>
+                  <a:ext uri="{0D108BD9-81ED-4DB2-BD59-A6C34878D82A}">
+                    <a16:rowId xmlns:a16="http://schemas.microsoft.com/office/drawing/2014/main" val="2656306186"/>
+                  </a:ext>
+                </a:extLst>
+              </a:tr>
+              <a:tr h="413193">
+                <a:tc>
+                  <a:txBody>
+                    <a:bodyPr/>
+                    <a:lstStyle/>
+                    <a:p>
+                      <a:pPr algn="ctr">
+                        <a:buNone/>
+                      </a:pPr>
+                      <a:r>
+                        <a:rPr lang="en-US" sz="900" dirty="0"/>
+                        <a:t>10</a:t>
+                      </a:r>
+                    </a:p>
+                  </a:txBody>
+                  <a:tcPr marL="44859" marR="44859" marT="22430" marB="22430" anchor="ctr">
+                    <a:lnL>
+                      <a:noFill/>
+                    </a:lnL>
+                    <a:lnR>
+                      <a:noFill/>
+                    </a:lnR>
+                    <a:lnT>
+                      <a:noFill/>
+                    </a:lnT>
+                    <a:lnB>
+                      <a:noFill/>
+                    </a:lnB>
+                    <a:noFill/>
+                  </a:tcPr>
+                </a:tc>
+                <a:tc>
+                  <a:txBody>
+                    <a:bodyPr/>
+                    <a:lstStyle/>
+                    <a:p>
+                      <a:pPr>
+                        <a:buNone/>
+                      </a:pPr>
+                      <a:r>
+                        <a:rPr lang="en-US" sz="900" dirty="0"/>
+                        <a:t>Profile Update &amp; Delete Account Module</a:t>
+                      </a:r>
+                    </a:p>
+                  </a:txBody>
+                  <a:tcPr marL="44859" marR="44859" marT="22430" marB="22430" anchor="ctr">
+                    <a:lnL>
+                      <a:noFill/>
+                    </a:lnL>
+                    <a:lnR>
+                      <a:noFill/>
+                    </a:lnR>
+                    <a:lnT>
+                      <a:noFill/>
+                    </a:lnT>
+                    <a:lnB>
+                      <a:noFill/>
+                    </a:lnB>
+                    <a:noFill/>
+                  </a:tcPr>
+                </a:tc>
+                <a:tc>
+                  <a:txBody>
+                    <a:bodyPr/>
+                    <a:lstStyle/>
+                    <a:p>
+                      <a:pPr algn="ctr">
+                        <a:buNone/>
+                      </a:pPr>
+                      <a:endParaRPr lang="en-US" sz="900"/>
+                    </a:p>
+                  </a:txBody>
+                  <a:tcPr marL="44859" marR="44859" marT="22430" marB="22430" anchor="ctr">
+                    <a:lnL>
+                      <a:noFill/>
+                    </a:lnL>
+                    <a:lnR>
+                      <a:noFill/>
+                    </a:lnR>
+                    <a:lnT>
+                      <a:noFill/>
+                    </a:lnT>
+                    <a:lnB>
+                      <a:noFill/>
+                    </a:lnB>
+                    <a:noFill/>
+                  </a:tcPr>
+                </a:tc>
+                <a:tc>
+                  <a:txBody>
+                    <a:bodyPr/>
+                    <a:lstStyle/>
+                    <a:p>
+                      <a:pPr algn="ctr">
+                        <a:buNone/>
+                      </a:pPr>
+                      <a:r>
+                        <a:rPr lang="en-US" sz="900"/>
+                        <a:t>✔</a:t>
+                      </a:r>
+                    </a:p>
+                  </a:txBody>
+                  <a:tcPr marL="44859" marR="44859" marT="22430" marB="22430" anchor="ctr">
+                    <a:lnL>
+                      <a:noFill/>
+                    </a:lnL>
+                    <a:lnR>
+                      <a:noFill/>
+                    </a:lnR>
+                    <a:lnT>
+                      <a:noFill/>
+                    </a:lnT>
+                    <a:lnB>
+                      <a:noFill/>
+                    </a:lnB>
+                    <a:noFill/>
+                  </a:tcPr>
+                </a:tc>
+                <a:extLst>
+                  <a:ext uri="{0D108BD9-81ED-4DB2-BD59-A6C34878D82A}">
+                    <a16:rowId xmlns:a16="http://schemas.microsoft.com/office/drawing/2014/main" val="2810022984"/>
+                  </a:ext>
+                </a:extLst>
+              </a:tr>
+              <a:tr h="413193">
+                <a:tc>
+                  <a:txBody>
+                    <a:bodyPr/>
+                    <a:lstStyle/>
+                    <a:p>
+                      <a:pPr algn="ctr">
+                        <a:buNone/>
+                      </a:pPr>
+                      <a:r>
+                        <a:rPr lang="en-US" sz="900" dirty="0"/>
+                        <a:t>11</a:t>
+                      </a:r>
+                    </a:p>
+                  </a:txBody>
+                  <a:tcPr marL="44859" marR="44859" marT="22430" marB="22430" anchor="ctr">
+                    <a:lnL>
+                      <a:noFill/>
+                    </a:lnL>
+                    <a:lnR>
+                      <a:noFill/>
+                    </a:lnR>
+                    <a:lnT>
+                      <a:noFill/>
+                    </a:lnT>
+                    <a:lnB>
+                      <a:noFill/>
+                    </a:lnB>
+                    <a:noFill/>
+                  </a:tcPr>
+                </a:tc>
+                <a:tc>
+                  <a:txBody>
+                    <a:bodyPr/>
+                    <a:lstStyle/>
+                    <a:p>
+                      <a:pPr>
+                        <a:buNone/>
+                      </a:pPr>
+                      <a:r>
+                        <a:rPr lang="en-US" sz="900" dirty="0"/>
+                        <a:t>File Handling (Binary File Storage)</a:t>
+                      </a:r>
+                    </a:p>
+                  </a:txBody>
+                  <a:tcPr marL="44859" marR="44859" marT="22430" marB="22430" anchor="ctr">
+                    <a:lnL>
+                      <a:noFill/>
+                    </a:lnL>
+                    <a:lnR>
+                      <a:noFill/>
+                    </a:lnR>
+                    <a:lnT>
+                      <a:noFill/>
+                    </a:lnT>
+                    <a:lnB>
+                      <a:noFill/>
+                    </a:lnB>
+                    <a:noFill/>
+                  </a:tcPr>
+                </a:tc>
+                <a:tc>
+                  <a:txBody>
+                    <a:bodyPr/>
+                    <a:lstStyle/>
+                    <a:p>
+                      <a:pPr algn="ctr">
+                        <a:buNone/>
+                      </a:pPr>
+                      <a:r>
+                        <a:rPr lang="en-US" sz="900" dirty="0"/>
+                        <a:t>✔</a:t>
+                      </a:r>
+                    </a:p>
+                  </a:txBody>
+                  <a:tcPr marL="44859" marR="44859" marT="22430" marB="22430" anchor="ctr">
+                    <a:lnL>
+                      <a:noFill/>
+                    </a:lnL>
+                    <a:lnR>
+                      <a:noFill/>
+                    </a:lnR>
+                    <a:lnT>
+                      <a:noFill/>
+                    </a:lnT>
+                    <a:lnB>
+                      <a:noFill/>
+                    </a:lnB>
+                    <a:noFill/>
+                  </a:tcPr>
+                </a:tc>
+                <a:tc>
+                  <a:txBody>
+                    <a:bodyPr/>
+                    <a:lstStyle/>
+                    <a:p>
+                      <a:pPr algn="ctr">
+                        <a:buNone/>
+                      </a:pPr>
+                      <a:r>
+                        <a:rPr lang="en-US" sz="900" dirty="0"/>
+                        <a:t>✔</a:t>
+                      </a:r>
+                    </a:p>
+                  </a:txBody>
+                  <a:tcPr marL="44859" marR="44859" marT="22430" marB="22430" anchor="ctr">
+                    <a:lnL>
+                      <a:noFill/>
+                    </a:lnL>
+                    <a:lnR>
+                      <a:noFill/>
+                    </a:lnR>
+                    <a:lnT>
+                      <a:noFill/>
+                    </a:lnT>
+                    <a:lnB>
+                      <a:noFill/>
+                    </a:lnB>
+                    <a:noFill/>
+                  </a:tcPr>
+                </a:tc>
+                <a:extLst>
+                  <a:ext uri="{0D108BD9-81ED-4DB2-BD59-A6C34878D82A}">
+                    <a16:rowId xmlns:a16="http://schemas.microsoft.com/office/drawing/2014/main" val="1498690962"/>
+                  </a:ext>
+                </a:extLst>
+              </a:tr>
+              <a:tr h="413193">
+                <a:tc>
+                  <a:txBody>
+                    <a:bodyPr/>
+                    <a:lstStyle/>
+                    <a:p>
+                      <a:pPr algn="ctr">
+                        <a:buNone/>
+                      </a:pPr>
+                      <a:r>
+                        <a:rPr lang="en-US" sz="900" dirty="0"/>
+                        <a:t>12</a:t>
+                      </a:r>
+                    </a:p>
+                  </a:txBody>
+                  <a:tcPr marL="44859" marR="44859" marT="22430" marB="22430" anchor="ctr">
+                    <a:lnL>
+                      <a:noFill/>
+                    </a:lnL>
+                    <a:lnR>
+                      <a:noFill/>
+                    </a:lnR>
+                    <a:lnT>
+                      <a:noFill/>
+                    </a:lnT>
+                    <a:lnB>
+                      <a:noFill/>
+                    </a:lnB>
+                    <a:noFill/>
+                  </a:tcPr>
+                </a:tc>
+                <a:tc>
+                  <a:txBody>
+                    <a:bodyPr/>
+                    <a:lstStyle/>
+                    <a:p>
+                      <a:pPr>
+                        <a:buNone/>
+                      </a:pPr>
+                      <a:r>
+                        <a:rPr lang="en-US" sz="900"/>
+                        <a:t>Testing (Test Cases, RTM &amp; UAT)</a:t>
+                      </a:r>
+                    </a:p>
+                  </a:txBody>
+                  <a:tcPr marL="44859" marR="44859" marT="22430" marB="22430" anchor="ctr">
+                    <a:lnL>
+                      <a:noFill/>
+                    </a:lnL>
+                    <a:lnR>
+                      <a:noFill/>
+                    </a:lnR>
+                    <a:lnT>
+                      <a:noFill/>
+                    </a:lnT>
+                    <a:lnB>
+                      <a:noFill/>
+                    </a:lnB>
+                    <a:noFill/>
+                  </a:tcPr>
+                </a:tc>
+                <a:tc>
+                  <a:txBody>
+                    <a:bodyPr/>
+                    <a:lstStyle/>
+                    <a:p>
+                      <a:pPr algn="ctr">
+                        <a:buNone/>
+                      </a:pPr>
+                      <a:r>
+                        <a:rPr lang="en-US" sz="900"/>
+                        <a:t>✔</a:t>
+                      </a:r>
+                    </a:p>
+                  </a:txBody>
+                  <a:tcPr marL="44859" marR="44859" marT="22430" marB="22430" anchor="ctr">
+                    <a:lnL>
+                      <a:noFill/>
+                    </a:lnL>
+                    <a:lnR>
+                      <a:noFill/>
+                    </a:lnR>
+                    <a:lnT>
+                      <a:noFill/>
+                    </a:lnT>
+                    <a:lnB>
+                      <a:noFill/>
+                    </a:lnB>
+                    <a:noFill/>
+                  </a:tcPr>
+                </a:tc>
+                <a:tc>
+                  <a:txBody>
+                    <a:bodyPr/>
+                    <a:lstStyle/>
+                    <a:p>
+                      <a:pPr algn="ctr">
+                        <a:buNone/>
+                      </a:pPr>
+                      <a:endParaRPr lang="en-US" sz="900" dirty="0"/>
+                    </a:p>
+                  </a:txBody>
+                  <a:tcPr marL="44859" marR="44859" marT="22430" marB="22430" anchor="ctr">
+                    <a:lnL>
+                      <a:noFill/>
+                    </a:lnL>
+                    <a:lnR>
+                      <a:noFill/>
+                    </a:lnR>
+                    <a:lnT>
+                      <a:noFill/>
+                    </a:lnT>
+                    <a:lnB>
+                      <a:noFill/>
+                    </a:lnB>
+                    <a:noFill/>
+                  </a:tcPr>
+                </a:tc>
+                <a:extLst>
+                  <a:ext uri="{0D108BD9-81ED-4DB2-BD59-A6C34878D82A}">
+                    <a16:rowId xmlns:a16="http://schemas.microsoft.com/office/drawing/2014/main" val="822979334"/>
+                  </a:ext>
+                </a:extLst>
+              </a:tr>
+              <a:tr h="413193">
+                <a:tc>
+                  <a:txBody>
+                    <a:bodyPr/>
+                    <a:lstStyle/>
+                    <a:p>
+                      <a:pPr algn="ctr">
+                        <a:buNone/>
+                      </a:pPr>
+                      <a:r>
+                        <a:rPr lang="en-US" sz="900" dirty="0"/>
+                        <a:t>13</a:t>
+                      </a:r>
+                    </a:p>
+                  </a:txBody>
+                  <a:tcPr marL="44859" marR="44859" marT="22430" marB="22430" anchor="ctr">
+                    <a:lnL>
+                      <a:noFill/>
+                    </a:lnL>
+                    <a:lnR>
+                      <a:noFill/>
+                    </a:lnR>
+                    <a:lnT>
+                      <a:noFill/>
+                    </a:lnT>
+                    <a:lnB>
+                      <a:noFill/>
+                    </a:lnB>
+                    <a:noFill/>
+                  </a:tcPr>
+                </a:tc>
+                <a:tc>
+                  <a:txBody>
+                    <a:bodyPr/>
+                    <a:lstStyle/>
+                    <a:p>
+                      <a:pPr>
+                        <a:buNone/>
+                      </a:pPr>
+                      <a:r>
+                        <a:rPr lang="en-US" sz="900"/>
+                        <a:t>Documentation &amp; Report Writing</a:t>
+                      </a:r>
+                    </a:p>
+                  </a:txBody>
+                  <a:tcPr marL="44859" marR="44859" marT="22430" marB="22430" anchor="ctr">
+                    <a:lnL>
+                      <a:noFill/>
+                    </a:lnL>
+                    <a:lnR>
+                      <a:noFill/>
+                    </a:lnR>
+                    <a:lnT>
+                      <a:noFill/>
+                    </a:lnT>
+                    <a:lnB>
+                      <a:noFill/>
+                    </a:lnB>
+                    <a:noFill/>
+                  </a:tcPr>
+                </a:tc>
+                <a:tc>
+                  <a:txBody>
+                    <a:bodyPr/>
+                    <a:lstStyle/>
+                    <a:p>
+                      <a:pPr algn="ctr">
+                        <a:buNone/>
+                      </a:pPr>
+                      <a:r>
+                        <a:rPr lang="en-US" sz="900"/>
+                        <a:t>✔</a:t>
+                      </a:r>
+                    </a:p>
+                  </a:txBody>
+                  <a:tcPr marL="44859" marR="44859" marT="22430" marB="22430" anchor="ctr">
+                    <a:lnL>
+                      <a:noFill/>
+                    </a:lnL>
+                    <a:lnR>
+                      <a:noFill/>
+                    </a:lnR>
+                    <a:lnT>
+                      <a:noFill/>
+                    </a:lnT>
+                    <a:lnB>
+                      <a:noFill/>
+                    </a:lnB>
+                    <a:noFill/>
+                  </a:tcPr>
+                </a:tc>
+                <a:tc>
+                  <a:txBody>
+                    <a:bodyPr/>
+                    <a:lstStyle/>
+                    <a:p>
+                      <a:pPr algn="ctr">
+                        <a:buNone/>
+                      </a:pPr>
+                      <a:r>
+                        <a:rPr lang="en-US" sz="900"/>
+                        <a:t>✔</a:t>
+                      </a:r>
+                    </a:p>
+                  </a:txBody>
+                  <a:tcPr marL="44859" marR="44859" marT="22430" marB="22430" anchor="ctr">
+                    <a:lnL>
+                      <a:noFill/>
+                    </a:lnL>
+                    <a:lnR>
+                      <a:noFill/>
+                    </a:lnR>
+                    <a:lnT>
+                      <a:noFill/>
+                    </a:lnT>
+                    <a:lnB>
+                      <a:noFill/>
+                    </a:lnB>
+                    <a:noFill/>
+                  </a:tcPr>
+                </a:tc>
+                <a:extLst>
+                  <a:ext uri="{0D108BD9-81ED-4DB2-BD59-A6C34878D82A}">
+                    <a16:rowId xmlns:a16="http://schemas.microsoft.com/office/drawing/2014/main" val="3667908517"/>
+                  </a:ext>
+                </a:extLst>
+              </a:tr>
+              <a:tr h="413193">
+                <a:tc>
+                  <a:txBody>
+                    <a:bodyPr/>
+                    <a:lstStyle/>
+                    <a:p>
+                      <a:pPr algn="ctr">
+                        <a:buNone/>
+                      </a:pPr>
+                      <a:r>
+                        <a:rPr lang="en-US" sz="900" dirty="0"/>
+                        <a:t>14</a:t>
+                      </a:r>
+                    </a:p>
+                  </a:txBody>
+                  <a:tcPr marL="44859" marR="44859" marT="22430" marB="22430" anchor="ctr">
+                    <a:lnL>
+                      <a:noFill/>
+                    </a:lnL>
+                    <a:lnR>
+                      <a:noFill/>
+                    </a:lnR>
+                    <a:lnT>
+                      <a:noFill/>
+                    </a:lnT>
+                    <a:lnB>
+                      <a:noFill/>
+                    </a:lnB>
+                    <a:noFill/>
+                  </a:tcPr>
+                </a:tc>
+                <a:tc>
+                  <a:txBody>
+                    <a:bodyPr/>
+                    <a:lstStyle/>
+                    <a:p>
+                      <a:pPr>
+                        <a:buNone/>
+                      </a:pPr>
+                      <a:r>
+                        <a:rPr lang="en-US" sz="900"/>
+                        <a:t>Presentation Preparation &amp; Project Demonstration</a:t>
+                      </a:r>
+                    </a:p>
+                  </a:txBody>
+                  <a:tcPr marL="44859" marR="44859" marT="22430" marB="22430" anchor="ctr">
+                    <a:lnL>
+                      <a:noFill/>
+                    </a:lnL>
+                    <a:lnR>
+                      <a:noFill/>
+                    </a:lnR>
+                    <a:lnT>
+                      <a:noFill/>
+                    </a:lnT>
+                    <a:lnB>
+                      <a:noFill/>
+                    </a:lnB>
+                    <a:noFill/>
+                  </a:tcPr>
+                </a:tc>
+                <a:tc>
+                  <a:txBody>
+                    <a:bodyPr/>
+                    <a:lstStyle/>
+                    <a:p>
+                      <a:pPr algn="ctr">
+                        <a:buNone/>
+                      </a:pPr>
+                      <a:r>
+                        <a:rPr lang="en-US" sz="900"/>
+                        <a:t>✔</a:t>
+                      </a:r>
+                    </a:p>
+                  </a:txBody>
+                  <a:tcPr marL="44859" marR="44859" marT="22430" marB="22430" anchor="ctr">
+                    <a:lnL>
+                      <a:noFill/>
+                    </a:lnL>
+                    <a:lnR>
+                      <a:noFill/>
+                    </a:lnR>
+                    <a:lnT>
+                      <a:noFill/>
+                    </a:lnT>
+                    <a:lnB>
+                      <a:noFill/>
+                    </a:lnB>
+                    <a:noFill/>
+                  </a:tcPr>
+                </a:tc>
+                <a:tc>
+                  <a:txBody>
+                    <a:bodyPr/>
+                    <a:lstStyle/>
+                    <a:p>
+                      <a:pPr algn="ctr">
+                        <a:buNone/>
+                      </a:pPr>
+                      <a:r>
+                        <a:rPr lang="en-US" sz="900" dirty="0"/>
+                        <a:t>✔</a:t>
+                      </a:r>
+                    </a:p>
+                  </a:txBody>
+                  <a:tcPr marL="44859" marR="44859" marT="22430" marB="22430" anchor="ctr">
+                    <a:lnL>
+                      <a:noFill/>
+                    </a:lnL>
+                    <a:lnR>
+                      <a:noFill/>
+                    </a:lnR>
+                    <a:lnT>
+                      <a:noFill/>
+                    </a:lnT>
+                    <a:lnB>
+                      <a:noFill/>
+                    </a:lnB>
+                    <a:noFill/>
+                  </a:tcPr>
+                </a:tc>
+                <a:extLst>
+                  <a:ext uri="{0D108BD9-81ED-4DB2-BD59-A6C34878D82A}">
+                    <a16:rowId xmlns:a16="http://schemas.microsoft.com/office/drawing/2014/main" val="4109677349"/>
+                  </a:ext>
+                </a:extLst>
+              </a:tr>
+            </a:tbl>
+          </a:graphicData>
+        </a:graphic>
+      </p:graphicFrame>
     </p:spTree>
     <p:extLst>
       <p:ext uri="{BB962C8B-B14F-4D97-AF65-F5344CB8AC3E}">
@@ -5553,10 +7582,12 @@
           <a:p>
             <a:pPr algn="ctr"/>
             <a:r>
-              <a:rPr lang="en-US" sz="6000" b="1" dirty="0" smtClean="0"/>
+              <a:rPr lang="en-US" b="1" dirty="0">
+                <a:latin typeface="Times New Roman" panose="02020603050405020304" pitchFamily="18" charset="0"/>
+                <a:cs typeface="Times New Roman" panose="02020603050405020304" pitchFamily="18" charset="0"/>
+              </a:rPr>
               <a:t>LEVEL 0 DFD </a:t>
             </a:r>
-            <a:endParaRPr lang="en-US" sz="6000" b="1" dirty="0"/>
           </a:p>
         </p:txBody>
       </p:sp>
@@ -5637,7 +7668,7 @@
               <a:buNone/>
               <a:tabLst/>
             </a:pPr>
-            <a:endParaRPr kumimoji="0" lang="en-US" sz="1800" b="0" i="0" u="none" strike="noStrike" cap="none" normalizeH="0" baseline="0" dirty="0" smtClean="0">
+            <a:endParaRPr kumimoji="0" lang="en-US" sz="1800" b="0" i="0" u="none" strike="noStrike" cap="none" normalizeH="0" baseline="0" dirty="0">
               <a:ln>
                 <a:noFill/>
               </a:ln>
@@ -5686,7 +7717,7 @@
               <a:buNone/>
               <a:tabLst/>
             </a:pPr>
-            <a:endParaRPr kumimoji="0" lang="en-US" sz="1800" b="0" i="0" u="none" strike="noStrike" cap="none" normalizeH="0" baseline="0" dirty="0" smtClean="0">
+            <a:endParaRPr kumimoji="0" lang="en-US" sz="1800" b="0" i="0" u="none" strike="noStrike" cap="none" normalizeH="0" baseline="0" dirty="0">
               <a:ln>
                 <a:noFill/>
               </a:ln>
@@ -5735,7 +7766,7 @@
               <a:buNone/>
               <a:tabLst/>
             </a:pPr>
-            <a:endParaRPr kumimoji="0" lang="en-US" sz="1800" b="0" i="0" u="none" strike="noStrike" cap="none" normalizeH="0" baseline="0" dirty="0" smtClean="0">
+            <a:endParaRPr kumimoji="0" lang="en-US" sz="1800" b="0" i="0" u="none" strike="noStrike" cap="none" normalizeH="0" baseline="0" dirty="0">
               <a:ln>
                 <a:noFill/>
               </a:ln>
@@ -5784,7 +7815,7 @@
               <a:buNone/>
               <a:tabLst/>
             </a:pPr>
-            <a:endParaRPr kumimoji="0" lang="en-US" sz="1800" b="0" i="0" u="none" strike="noStrike" cap="none" normalizeH="0" baseline="0" dirty="0" smtClean="0">
+            <a:endParaRPr kumimoji="0" lang="en-US" sz="1800" b="0" i="0" u="none" strike="noStrike" cap="none" normalizeH="0" baseline="0" dirty="0">
               <a:ln>
                 <a:noFill/>
               </a:ln>
@@ -5833,7 +7864,7 @@
               <a:buNone/>
               <a:tabLst/>
             </a:pPr>
-            <a:endParaRPr kumimoji="0" lang="en-US" sz="1800" b="0" i="0" u="none" strike="noStrike" cap="none" normalizeH="0" baseline="0" dirty="0" smtClean="0">
+            <a:endParaRPr kumimoji="0" lang="en-US" sz="1800" b="0" i="0" u="none" strike="noStrike" cap="none" normalizeH="0" baseline="0" dirty="0">
               <a:ln>
                 <a:noFill/>
               </a:ln>
@@ -5882,7 +7913,7 @@
               <a:buNone/>
               <a:tabLst/>
             </a:pPr>
-            <a:endParaRPr kumimoji="0" lang="en-US" sz="1800" b="0" i="0" u="none" strike="noStrike" cap="none" normalizeH="0" baseline="0" dirty="0" smtClean="0">
+            <a:endParaRPr kumimoji="0" lang="en-US" sz="1800" b="0" i="0" u="none" strike="noStrike" cap="none" normalizeH="0" baseline="0" dirty="0">
               <a:ln>
                 <a:noFill/>
               </a:ln>
@@ -5910,7 +7941,7 @@
               <a:buNone/>
               <a:tabLst/>
             </a:pPr>
-            <a:endParaRPr kumimoji="0" lang="en-US" sz="1800" b="0" i="0" u="none" strike="noStrike" cap="none" normalizeH="0" baseline="0" dirty="0" smtClean="0">
+            <a:endParaRPr kumimoji="0" lang="en-US" sz="1800" b="0" i="0" u="none" strike="noStrike" cap="none" normalizeH="0" baseline="0" dirty="0">
               <a:ln>
                 <a:noFill/>
               </a:ln>
@@ -5939,7 +7970,7 @@
               <a:tabLst/>
             </a:pPr>
             <a:r>
-              <a:rPr kumimoji="0" lang="en-US" sz="2000" b="0" i="0" u="none" strike="noStrike" cap="none" normalizeH="0" baseline="0" dirty="0" smtClean="0">
+              <a:rPr kumimoji="0" lang="en-US" sz="2000" b="0" i="0" u="none" strike="noStrike" cap="none" normalizeH="0" baseline="0" dirty="0">
                 <a:ln>
                   <a:noFill/>
                 </a:ln>
@@ -5970,7 +8001,7 @@
               <a:tabLst/>
             </a:pPr>
             <a:r>
-              <a:rPr kumimoji="0" lang="en-US" sz="2000" b="0" i="0" u="none" strike="noStrike" cap="none" normalizeH="0" baseline="0" dirty="0" smtClean="0">
+              <a:rPr kumimoji="0" lang="en-US" sz="2000" b="0" i="0" u="none" strike="noStrike" cap="none" normalizeH="0" baseline="0" dirty="0">
                 <a:ln>
                   <a:noFill/>
                 </a:ln>
@@ -6001,7 +8032,7 @@
               <a:tabLst/>
             </a:pPr>
             <a:r>
-              <a:rPr kumimoji="0" lang="en-US" sz="2000" b="0" i="0" u="none" strike="noStrike" cap="none" normalizeH="0" baseline="0" dirty="0" smtClean="0">
+              <a:rPr kumimoji="0" lang="en-US" sz="2000" b="0" i="0" u="none" strike="noStrike" cap="none" normalizeH="0" baseline="0" dirty="0">
                 <a:ln>
                   <a:noFill/>
                 </a:ln>
@@ -6093,10 +8124,12 @@
           <a:p>
             <a:pPr algn="ctr"/>
             <a:r>
-              <a:rPr lang="en-US" sz="6000" b="1" dirty="0" smtClean="0"/>
+              <a:rPr lang="en-US" b="1" dirty="0">
+                <a:latin typeface="Times New Roman" panose="02020603050405020304" pitchFamily="18" charset="0"/>
+                <a:cs typeface="Times New Roman" panose="02020603050405020304" pitchFamily="18" charset="0"/>
+              </a:rPr>
               <a:t>LEVEL 1 DFD</a:t>
             </a:r>
-            <a:endParaRPr lang="en-US" sz="6000" b="1" dirty="0"/>
           </a:p>
         </p:txBody>
       </p:sp>
@@ -6177,7 +8210,7 @@
               <a:buNone/>
               <a:tabLst/>
             </a:pPr>
-            <a:endParaRPr kumimoji="0" lang="en-US" sz="1800" b="0" i="0" u="none" strike="noStrike" cap="none" normalizeH="0" baseline="0" dirty="0" smtClean="0">
+            <a:endParaRPr kumimoji="0" lang="en-US" sz="1800" b="0" i="0" u="none" strike="noStrike" cap="none" normalizeH="0" baseline="0" dirty="0">
               <a:ln>
                 <a:noFill/>
               </a:ln>
@@ -6226,7 +8259,7 @@
               <a:buNone/>
               <a:tabLst/>
             </a:pPr>
-            <a:endParaRPr kumimoji="0" lang="en-US" sz="1800" b="0" i="0" u="none" strike="noStrike" cap="none" normalizeH="0" baseline="0" dirty="0" smtClean="0">
+            <a:endParaRPr kumimoji="0" lang="en-US" sz="1800" b="0" i="0" u="none" strike="noStrike" cap="none" normalizeH="0" baseline="0" dirty="0">
               <a:ln>
                 <a:noFill/>
               </a:ln>
@@ -6275,7 +8308,7 @@
               <a:buNone/>
               <a:tabLst/>
             </a:pPr>
-            <a:endParaRPr kumimoji="0" lang="en-US" sz="1800" b="0" i="0" u="none" strike="noStrike" cap="none" normalizeH="0" baseline="0" dirty="0" smtClean="0">
+            <a:endParaRPr kumimoji="0" lang="en-US" sz="1800" b="0" i="0" u="none" strike="noStrike" cap="none" normalizeH="0" baseline="0" dirty="0">
               <a:ln>
                 <a:noFill/>
               </a:ln>
@@ -6324,7 +8357,7 @@
               <a:buNone/>
               <a:tabLst/>
             </a:pPr>
-            <a:endParaRPr kumimoji="0" lang="en-US" sz="1800" b="0" i="0" u="none" strike="noStrike" cap="none" normalizeH="0" baseline="0" dirty="0" smtClean="0">
+            <a:endParaRPr kumimoji="0" lang="en-US" sz="1800" b="0" i="0" u="none" strike="noStrike" cap="none" normalizeH="0" baseline="0" dirty="0">
               <a:ln>
                 <a:noFill/>
               </a:ln>
@@ -6373,7 +8406,7 @@
               <a:buNone/>
               <a:tabLst/>
             </a:pPr>
-            <a:endParaRPr kumimoji="0" lang="en-US" sz="1800" b="0" i="0" u="none" strike="noStrike" cap="none" normalizeH="0" baseline="0" dirty="0" smtClean="0">
+            <a:endParaRPr kumimoji="0" lang="en-US" sz="1800" b="0" i="0" u="none" strike="noStrike" cap="none" normalizeH="0" baseline="0" dirty="0">
               <a:ln>
                 <a:noFill/>
               </a:ln>
@@ -6422,7 +8455,7 @@
               <a:buNone/>
               <a:tabLst/>
             </a:pPr>
-            <a:endParaRPr kumimoji="0" lang="en-US" sz="1800" b="0" i="0" u="none" strike="noStrike" cap="none" normalizeH="0" baseline="0" dirty="0" smtClean="0">
+            <a:endParaRPr kumimoji="0" lang="en-US" sz="1800" b="0" i="0" u="none" strike="noStrike" cap="none" normalizeH="0" baseline="0" dirty="0">
               <a:ln>
                 <a:noFill/>
               </a:ln>
@@ -6450,7 +8483,7 @@
               <a:buNone/>
               <a:tabLst/>
             </a:pPr>
-            <a:endParaRPr kumimoji="0" lang="en-US" sz="1800" b="0" i="0" u="none" strike="noStrike" cap="none" normalizeH="0" baseline="0" dirty="0" smtClean="0">
+            <a:endParaRPr kumimoji="0" lang="en-US" sz="1800" b="0" i="0" u="none" strike="noStrike" cap="none" normalizeH="0" baseline="0" dirty="0">
               <a:ln>
                 <a:noFill/>
               </a:ln>
@@ -6499,7 +8532,7 @@
               <a:buNone/>
               <a:tabLst/>
             </a:pPr>
-            <a:endParaRPr kumimoji="0" lang="en-US" sz="1800" b="0" i="0" u="none" strike="noStrike" cap="none" normalizeH="0" baseline="0" dirty="0" smtClean="0">
+            <a:endParaRPr kumimoji="0" lang="en-US" sz="1800" b="0" i="0" u="none" strike="noStrike" cap="none" normalizeH="0" baseline="0" dirty="0">
               <a:ln>
                 <a:noFill/>
               </a:ln>
@@ -6548,7 +8581,7 @@
               <a:buNone/>
               <a:tabLst/>
             </a:pPr>
-            <a:endParaRPr kumimoji="0" lang="en-US" sz="1800" b="0" i="0" u="none" strike="noStrike" cap="none" normalizeH="0" baseline="0" dirty="0" smtClean="0">
+            <a:endParaRPr kumimoji="0" lang="en-US" sz="1800" b="0" i="0" u="none" strike="noStrike" cap="none" normalizeH="0" baseline="0" dirty="0">
               <a:ln>
                 <a:noFill/>
               </a:ln>
@@ -6577,7 +8610,7 @@
               <a:tabLst/>
             </a:pPr>
             <a:r>
-              <a:rPr kumimoji="0" lang="en-US" sz="1800" b="0" i="0" u="none" strike="noStrike" cap="none" normalizeH="0" baseline="0" dirty="0" smtClean="0">
+              <a:rPr kumimoji="0" lang="en-US" sz="1800" b="0" i="0" u="none" strike="noStrike" cap="none" normalizeH="0" baseline="0" dirty="0">
                 <a:ln>
                   <a:noFill/>
                 </a:ln>
@@ -6608,7 +8641,7 @@
               <a:tabLst/>
             </a:pPr>
             <a:r>
-              <a:rPr kumimoji="0" lang="en-US" sz="1800" b="0" i="0" u="none" strike="noStrike" cap="none" normalizeH="0" baseline="0" dirty="0" smtClean="0">
+              <a:rPr kumimoji="0" lang="en-US" sz="1800" b="0" i="0" u="none" strike="noStrike" cap="none" normalizeH="0" baseline="0" dirty="0">
                 <a:ln>
                   <a:noFill/>
                 </a:ln>
@@ -6639,7 +8672,7 @@
               <a:tabLst/>
             </a:pPr>
             <a:r>
-              <a:rPr kumimoji="0" lang="en-US" sz="1800" b="0" i="0" u="none" strike="noStrike" cap="none" normalizeH="0" baseline="0" dirty="0" smtClean="0">
+              <a:rPr kumimoji="0" lang="en-US" sz="1800" b="0" i="0" u="none" strike="noStrike" cap="none" normalizeH="0" baseline="0" dirty="0">
                 <a:ln>
                   <a:noFill/>
                 </a:ln>
@@ -6724,8 +8757,8 @@
         </p:nvSpPr>
         <p:spPr>
           <a:xfrm>
-            <a:off x="0" y="-333375"/>
-            <a:ext cx="10515600" cy="1325563"/>
+            <a:off x="217714" y="208476"/>
+            <a:ext cx="10297886" cy="783712"/>
           </a:xfrm>
         </p:spPr>
         <p:txBody>
@@ -6736,10 +8769,12 @@
           <a:p>
             <a:pPr algn="ctr"/>
             <a:r>
-              <a:rPr lang="en-US" sz="3200" b="1" dirty="0" smtClean="0"/>
+              <a:rPr lang="en-US" sz="3200" b="1" dirty="0">
+                <a:latin typeface="Times New Roman" panose="02020603050405020304" pitchFamily="18" charset="0"/>
+                <a:cs typeface="Times New Roman" panose="02020603050405020304" pitchFamily="18" charset="0"/>
+              </a:rPr>
               <a:t>FLOWCHART FOR MAIN MENU, REGISTRATION AND LOGIN</a:t>
             </a:r>
-            <a:endParaRPr lang="en-US" sz="3200" b="1" dirty="0"/>
           </a:p>
         </p:txBody>
       </p:sp>
@@ -6820,7 +8855,7 @@
               <a:buNone/>
               <a:tabLst/>
             </a:pPr>
-            <a:endParaRPr kumimoji="0" lang="en-US" sz="1800" b="0" i="0" u="none" strike="noStrike" cap="none" normalizeH="0" baseline="0" dirty="0" smtClean="0">
+            <a:endParaRPr kumimoji="0" lang="en-US" sz="1800" b="0" i="0" u="none" strike="noStrike" cap="none" normalizeH="0" baseline="0" dirty="0">
               <a:ln>
                 <a:noFill/>
               </a:ln>
@@ -6869,7 +8904,7 @@
               <a:buNone/>
               <a:tabLst/>
             </a:pPr>
-            <a:endParaRPr kumimoji="0" lang="en-US" sz="1800" b="0" i="0" u="none" strike="noStrike" cap="none" normalizeH="0" baseline="0" dirty="0" smtClean="0">
+            <a:endParaRPr kumimoji="0" lang="en-US" sz="1800" b="0" i="0" u="none" strike="noStrike" cap="none" normalizeH="0" baseline="0" dirty="0">
               <a:ln>
                 <a:noFill/>
               </a:ln>
@@ -6918,7 +8953,7 @@
               <a:buNone/>
               <a:tabLst/>
             </a:pPr>
-            <a:endParaRPr kumimoji="0" lang="en-US" sz="1800" b="0" i="0" u="none" strike="noStrike" cap="none" normalizeH="0" baseline="0" dirty="0" smtClean="0">
+            <a:endParaRPr kumimoji="0" lang="en-US" sz="1800" b="0" i="0" u="none" strike="noStrike" cap="none" normalizeH="0" baseline="0" dirty="0">
               <a:ln>
                 <a:noFill/>
               </a:ln>
@@ -6967,7 +9002,7 @@
               <a:buNone/>
               <a:tabLst/>
             </a:pPr>
-            <a:endParaRPr kumimoji="0" lang="en-US" sz="1800" b="0" i="0" u="none" strike="noStrike" cap="none" normalizeH="0" baseline="0" dirty="0" smtClean="0">
+            <a:endParaRPr kumimoji="0" lang="en-US" sz="1800" b="0" i="0" u="none" strike="noStrike" cap="none" normalizeH="0" baseline="0" dirty="0">
               <a:ln>
                 <a:noFill/>
               </a:ln>
@@ -7016,7 +9051,7 @@
               <a:buNone/>
               <a:tabLst/>
             </a:pPr>
-            <a:endParaRPr kumimoji="0" lang="en-US" sz="1800" b="0" i="0" u="none" strike="noStrike" cap="none" normalizeH="0" baseline="0" dirty="0" smtClean="0">
+            <a:endParaRPr kumimoji="0" lang="en-US" sz="1800" b="0" i="0" u="none" strike="noStrike" cap="none" normalizeH="0" baseline="0" dirty="0">
               <a:ln>
                 <a:noFill/>
               </a:ln>
@@ -7065,7 +9100,7 @@
               <a:buNone/>
               <a:tabLst/>
             </a:pPr>
-            <a:endParaRPr kumimoji="0" lang="en-US" sz="1800" b="0" i="0" u="none" strike="noStrike" cap="none" normalizeH="0" baseline="0" dirty="0" smtClean="0">
+            <a:endParaRPr kumimoji="0" lang="en-US" sz="1800" b="0" i="0" u="none" strike="noStrike" cap="none" normalizeH="0" baseline="0" dirty="0">
               <a:ln>
                 <a:noFill/>
               </a:ln>
@@ -7114,7 +9149,7 @@
               <a:buNone/>
               <a:tabLst/>
             </a:pPr>
-            <a:endParaRPr kumimoji="0" lang="en-US" sz="1800" b="0" i="0" u="none" strike="noStrike" cap="none" normalizeH="0" baseline="0" dirty="0" smtClean="0">
+            <a:endParaRPr kumimoji="0" lang="en-US" sz="1800" b="0" i="0" u="none" strike="noStrike" cap="none" normalizeH="0" baseline="0" dirty="0">
               <a:ln>
                 <a:noFill/>
               </a:ln>
@@ -7163,7 +9198,7 @@
               <a:buNone/>
               <a:tabLst/>
             </a:pPr>
-            <a:endParaRPr kumimoji="0" lang="en-US" sz="1800" b="0" i="0" u="none" strike="noStrike" cap="none" normalizeH="0" baseline="0" dirty="0" smtClean="0">
+            <a:endParaRPr kumimoji="0" lang="en-US" sz="1800" b="0" i="0" u="none" strike="noStrike" cap="none" normalizeH="0" baseline="0" dirty="0">
               <a:ln>
                 <a:noFill/>
               </a:ln>
@@ -7212,7 +9247,7 @@
               <a:buNone/>
               <a:tabLst/>
             </a:pPr>
-            <a:endParaRPr kumimoji="0" lang="en-US" sz="1800" b="0" i="0" u="none" strike="noStrike" cap="none" normalizeH="0" baseline="0" dirty="0" smtClean="0">
+            <a:endParaRPr kumimoji="0" lang="en-US" sz="1800" b="0" i="0" u="none" strike="noStrike" cap="none" normalizeH="0" baseline="0" dirty="0">
               <a:ln>
                 <a:noFill/>
               </a:ln>
@@ -7240,7 +9275,7 @@
               <a:buNone/>
               <a:tabLst/>
             </a:pPr>
-            <a:endParaRPr kumimoji="0" lang="en-US" sz="1800" b="0" i="0" u="none" strike="noStrike" cap="none" normalizeH="0" baseline="0" dirty="0" smtClean="0">
+            <a:endParaRPr kumimoji="0" lang="en-US" sz="1800" b="0" i="0" u="none" strike="noStrike" cap="none" normalizeH="0" baseline="0" dirty="0">
               <a:ln>
                 <a:noFill/>
               </a:ln>
@@ -7285,7 +9320,7 @@
               </a:spcAft>
               <a:buNone/>
             </a:pPr>
-            <a:endParaRPr lang="en-US" sz="1800" dirty="0" smtClean="0"/>
+            <a:endParaRPr lang="en-US" sz="1800" dirty="0"/>
           </a:p>
           <a:p>
             <a:pPr eaLnBrk="0" fontAlgn="base" hangingPunct="0">
@@ -7300,16 +9335,8 @@
               </a:spcAft>
             </a:pPr>
             <a:r>
-              <a:rPr lang="en-US" sz="1800" dirty="0" smtClean="0"/>
-              <a:t>Illustrates </a:t>
-            </a:r>
-            <a:r>
               <a:rPr lang="en-US" sz="1800" dirty="0"/>
-              <a:t>the sequence of user registration and login before accessing the game dashboard</a:t>
-            </a:r>
-            <a:r>
-              <a:rPr lang="en-US" sz="1800" dirty="0" smtClean="0"/>
-              <a:t>.</a:t>
+              <a:t>Illustrates the sequence of user registration and login before accessing the game dashboard.</a:t>
             </a:r>
           </a:p>
         </p:txBody>
@@ -7334,8 +9361,8 @@
         </p:blipFill>
         <p:spPr>
           <a:xfrm>
-            <a:off x="838200" y="590550"/>
-            <a:ext cx="9953625" cy="6048375"/>
+            <a:off x="914400" y="676547"/>
+            <a:ext cx="10069286" cy="5811339"/>
           </a:xfrm>
           <a:prstGeom prst="rect">
             <a:avLst/>
@@ -7394,10 +9421,12 @@
           <a:p>
             <a:pPr algn="ctr"/>
             <a:r>
-              <a:rPr lang="en-US" b="1" dirty="0" smtClean="0"/>
+              <a:rPr lang="en-US" b="1" dirty="0">
+                <a:latin typeface="Times New Roman" panose="02020603050405020304" pitchFamily="18" charset="0"/>
+                <a:cs typeface="Times New Roman" panose="02020603050405020304" pitchFamily="18" charset="0"/>
+              </a:rPr>
               <a:t>FLOWCHART FOR DASHBOARD</a:t>
             </a:r>
-            <a:endParaRPr lang="en-US" b="1" dirty="0"/>
           </a:p>
         </p:txBody>
       </p:sp>
@@ -7413,8 +9442,8 @@
         </p:nvSpPr>
         <p:spPr bwMode="auto">
           <a:xfrm>
-            <a:off x="0" y="384603"/>
-            <a:ext cx="11157863" cy="6463308"/>
+            <a:off x="620486" y="240789"/>
+            <a:ext cx="9535885" cy="6740307"/>
           </a:xfrm>
           <a:prstGeom prst="rect">
             <a:avLst/>
@@ -7454,7 +9483,7 @@
           </a:extLst>
         </p:spPr>
         <p:txBody>
-          <a:bodyPr vert="horz" wrap="none" lIns="91440" tIns="45720" rIns="91440" bIns="45720" numCol="1" anchor="ctr" anchorCtr="0" compatLnSpc="1">
+          <a:bodyPr vert="horz" wrap="square" lIns="91440" tIns="45720" rIns="91440" bIns="45720" numCol="1" anchor="ctr" anchorCtr="0" compatLnSpc="1">
             <a:prstTxWarp prst="textNoShape">
               <a:avLst/>
             </a:prstTxWarp>
@@ -7478,7 +9507,7 @@
               <a:buNone/>
               <a:tabLst/>
             </a:pPr>
-            <a:endParaRPr kumimoji="0" lang="en-US" sz="1800" i="0" u="none" strike="noStrike" cap="none" normalizeH="0" baseline="0" dirty="0" smtClean="0">
+            <a:endParaRPr kumimoji="0" lang="en-US" sz="1800" i="0" u="none" strike="noStrike" cap="none" normalizeH="0" baseline="0" dirty="0">
               <a:ln>
                 <a:noFill/>
               </a:ln>
@@ -7527,7 +9556,7 @@
               <a:buNone/>
               <a:tabLst/>
             </a:pPr>
-            <a:endParaRPr kumimoji="0" lang="en-US" sz="1800" i="0" u="none" strike="noStrike" cap="none" normalizeH="0" baseline="0" dirty="0" smtClean="0">
+            <a:endParaRPr kumimoji="0" lang="en-US" sz="1800" i="0" u="none" strike="noStrike" cap="none" normalizeH="0" baseline="0" dirty="0">
               <a:ln>
                 <a:noFill/>
               </a:ln>
@@ -7576,7 +9605,7 @@
               <a:buNone/>
               <a:tabLst/>
             </a:pPr>
-            <a:endParaRPr kumimoji="0" lang="en-US" sz="1800" i="0" u="none" strike="noStrike" cap="none" normalizeH="0" baseline="0" dirty="0" smtClean="0">
+            <a:endParaRPr kumimoji="0" lang="en-US" sz="1800" i="0" u="none" strike="noStrike" cap="none" normalizeH="0" baseline="0" dirty="0">
               <a:ln>
                 <a:noFill/>
               </a:ln>
@@ -7625,7 +9654,7 @@
               <a:buNone/>
               <a:tabLst/>
             </a:pPr>
-            <a:endParaRPr kumimoji="0" lang="en-US" sz="1800" i="0" u="none" strike="noStrike" cap="none" normalizeH="0" baseline="0" dirty="0" smtClean="0">
+            <a:endParaRPr kumimoji="0" lang="en-US" sz="1800" i="0" u="none" strike="noStrike" cap="none" normalizeH="0" baseline="0" dirty="0">
               <a:ln>
                 <a:noFill/>
               </a:ln>
@@ -7674,7 +9703,7 @@
               <a:buNone/>
               <a:tabLst/>
             </a:pPr>
-            <a:endParaRPr kumimoji="0" lang="en-US" sz="1800" i="0" u="none" strike="noStrike" cap="none" normalizeH="0" baseline="0" dirty="0" smtClean="0">
+            <a:endParaRPr kumimoji="0" lang="en-US" sz="1800" i="0" u="none" strike="noStrike" cap="none" normalizeH="0" baseline="0" dirty="0">
               <a:ln>
                 <a:noFill/>
               </a:ln>
@@ -7723,7 +9752,7 @@
               <a:buNone/>
               <a:tabLst/>
             </a:pPr>
-            <a:endParaRPr kumimoji="0" lang="en-US" sz="1800" i="0" u="none" strike="noStrike" cap="none" normalizeH="0" baseline="0" dirty="0" smtClean="0">
+            <a:endParaRPr kumimoji="0" lang="en-US" sz="1800" i="0" u="none" strike="noStrike" cap="none" normalizeH="0" baseline="0" dirty="0">
               <a:ln>
                 <a:noFill/>
               </a:ln>
@@ -7772,7 +9801,7 @@
               <a:buNone/>
               <a:tabLst/>
             </a:pPr>
-            <a:endParaRPr kumimoji="0" lang="en-US" sz="1800" i="0" u="none" strike="noStrike" cap="none" normalizeH="0" baseline="0" dirty="0" smtClean="0">
+            <a:endParaRPr kumimoji="0" lang="en-US" sz="1800" i="0" u="none" strike="noStrike" cap="none" normalizeH="0" baseline="0" dirty="0">
               <a:ln>
                 <a:noFill/>
               </a:ln>
@@ -7821,7 +9850,7 @@
               <a:buNone/>
               <a:tabLst/>
             </a:pPr>
-            <a:endParaRPr kumimoji="0" lang="en-US" sz="1800" i="0" u="none" strike="noStrike" cap="none" normalizeH="0" baseline="0" dirty="0" smtClean="0">
+            <a:endParaRPr kumimoji="0" lang="en-US" sz="1800" i="0" u="none" strike="noStrike" cap="none" normalizeH="0" baseline="0" dirty="0">
               <a:ln>
                 <a:noFill/>
               </a:ln>
@@ -7870,7 +9899,7 @@
               <a:buNone/>
               <a:tabLst/>
             </a:pPr>
-            <a:endParaRPr kumimoji="0" lang="en-US" sz="1800" i="0" u="none" strike="noStrike" cap="none" normalizeH="0" baseline="0" dirty="0" smtClean="0">
+            <a:endParaRPr kumimoji="0" lang="en-US" sz="1800" i="0" u="none" strike="noStrike" cap="none" normalizeH="0" baseline="0" dirty="0">
               <a:ln>
                 <a:noFill/>
               </a:ln>
@@ -7898,7 +9927,7 @@
               <a:buNone/>
               <a:tabLst/>
             </a:pPr>
-            <a:endParaRPr lang="en-US" sz="1800" dirty="0" smtClean="0">
+            <a:endParaRPr lang="en-US" sz="1800" dirty="0">
               <a:latin typeface="Arial" panose="020B0604020202020204" pitchFamily="34" charset="0"/>
             </a:endParaRPr>
           </a:p>
@@ -7940,7 +9969,7 @@
               <a:buNone/>
               <a:tabLst/>
             </a:pPr>
-            <a:endParaRPr lang="en-US" sz="1800" dirty="0" smtClean="0">
+            <a:endParaRPr lang="en-US" sz="1800" dirty="0">
               <a:latin typeface="Arial" panose="020B0604020202020204" pitchFamily="34" charset="0"/>
             </a:endParaRPr>
           </a:p>
@@ -7982,7 +10011,7 @@
               <a:buNone/>
               <a:tabLst/>
             </a:pPr>
-            <a:endParaRPr kumimoji="0" lang="en-US" sz="1800" i="0" u="none" strike="noStrike" cap="none" normalizeH="0" baseline="0" dirty="0" smtClean="0">
+            <a:endParaRPr kumimoji="0" lang="en-US" sz="1800" i="0" u="none" strike="noStrike" cap="none" normalizeH="0" baseline="0" dirty="0">
               <a:ln>
                 <a:noFill/>
               </a:ln>
@@ -8006,7 +10035,7 @@
               </a:spcAft>
             </a:pPr>
             <a:r>
-              <a:rPr kumimoji="0" lang="en-US" sz="1800" i="0" u="none" strike="noStrike" cap="none" normalizeH="0" baseline="0" dirty="0" smtClean="0">
+              <a:rPr kumimoji="0" lang="en-US" sz="1800" i="0" u="none" strike="noStrike" cap="none" normalizeH="0" baseline="0" dirty="0">
                 <a:ln>
                   <a:noFill/>
                 </a:ln>
@@ -8041,7 +10070,7 @@
         </p:blipFill>
         <p:spPr>
           <a:xfrm>
-            <a:off x="400040" y="850832"/>
+            <a:off x="400040" y="805977"/>
             <a:ext cx="11258560" cy="5530850"/>
           </a:xfrm>
           <a:prstGeom prst="rect">

</xml_diff>